<commit_message>
added pdf to folder
</commit_message>
<xml_diff>
--- a/Week 1/wk1_PHYS3116_2026T3_spotted_python_slides.pptx
+++ b/Week 1/wk1_PHYS3116_2026T3_spotted_python_slides.pptx
@@ -7,10 +7,10 @@
     <p:sldMasterId id="2147483681" r:id="rId6"/>
   </p:sldMasterIdLst>
   <p:notesMasterIdLst>
-    <p:notesMasterId r:id="rId22"/>
+    <p:notesMasterId r:id="rId23"/>
   </p:notesMasterIdLst>
   <p:handoutMasterIdLst>
-    <p:handoutMasterId r:id="rId23"/>
+    <p:handoutMasterId r:id="rId24"/>
   </p:handoutMasterIdLst>
   <p:sldIdLst>
     <p:sldId id="258" r:id="rId7"/>
@@ -24,10 +24,11 @@
     <p:sldId id="291" r:id="rId15"/>
     <p:sldId id="292" r:id="rId16"/>
     <p:sldId id="307" r:id="rId17"/>
-    <p:sldId id="295" r:id="rId18"/>
-    <p:sldId id="296" r:id="rId19"/>
-    <p:sldId id="297" r:id="rId20"/>
+    <p:sldId id="308" r:id="rId18"/>
+    <p:sldId id="309" r:id="rId19"/>
+    <p:sldId id="310" r:id="rId20"/>
     <p:sldId id="298" r:id="rId21"/>
+    <p:sldId id="311" r:id="rId22"/>
   </p:sldIdLst>
   <p:sldSz cx="12192000" cy="6858000"/>
   <p:notesSz cx="6858000" cy="9144000"/>
@@ -751,90 +752,6 @@
     <p:extLst>
       <p:ext uri="{BB962C8B-B14F-4D97-AF65-F5344CB8AC3E}">
         <p14:creationId xmlns:p14="http://schemas.microsoft.com/office/powerpoint/2010/main" val="3255794454"/>
-      </p:ext>
-    </p:extLst>
-  </p:cSld>
-  <p:clrMapOvr>
-    <a:masterClrMapping/>
-  </p:clrMapOvr>
-</p:notes>
-</file>
-
-<file path=ppt/notesSlides/notesSlide2.xml><?xml version="1.0" encoding="utf-8"?>
-<p:notes xmlns:a="http://schemas.openxmlformats.org/drawingml/2006/main" xmlns:r="http://schemas.openxmlformats.org/officeDocument/2006/relationships" xmlns:p="http://schemas.openxmlformats.org/presentationml/2006/main">
-  <p:cSld>
-    <p:spTree>
-      <p:nvGrpSpPr>
-        <p:cNvPr id="1" name=""/>
-        <p:cNvGrpSpPr/>
-        <p:nvPr/>
-      </p:nvGrpSpPr>
-      <p:grpSpPr>
-        <a:xfrm>
-          <a:off x="0" y="0"/>
-          <a:ext cx="0" cy="0"/>
-          <a:chOff x="0" y="0"/>
-          <a:chExt cx="0" cy="0"/>
-        </a:xfrm>
-      </p:grpSpPr>
-      <p:sp>
-        <p:nvSpPr>
-          <p:cNvPr id="2" name="Slide Image Placeholder 1"/>
-          <p:cNvSpPr>
-            <a:spLocks noGrp="1" noRot="1" noChangeAspect="1"/>
-          </p:cNvSpPr>
-          <p:nvPr>
-            <p:ph type="sldImg"/>
-          </p:nvPr>
-        </p:nvSpPr>
-        <p:spPr/>
-      </p:sp>
-      <p:sp>
-        <p:nvSpPr>
-          <p:cNvPr id="3" name="Notes Placeholder 2"/>
-          <p:cNvSpPr>
-            <a:spLocks noGrp="1"/>
-          </p:cNvSpPr>
-          <p:nvPr>
-            <p:ph type="body" idx="1"/>
-          </p:nvPr>
-        </p:nvSpPr>
-        <p:spPr/>
-        <p:txBody>
-          <a:bodyPr/>
-          <a:lstStyle/>
-          <a:p>
-            <a:endParaRPr lang="en-AU" dirty="0"/>
-          </a:p>
-        </p:txBody>
-      </p:sp>
-      <p:sp>
-        <p:nvSpPr>
-          <p:cNvPr id="4" name="Slide Number Placeholder 3"/>
-          <p:cNvSpPr>
-            <a:spLocks noGrp="1"/>
-          </p:cNvSpPr>
-          <p:nvPr>
-            <p:ph type="sldNum" sz="quarter" idx="5"/>
-          </p:nvPr>
-        </p:nvSpPr>
-        <p:spPr/>
-        <p:txBody>
-          <a:bodyPr/>
-          <a:lstStyle/>
-          <a:p>
-            <a:fld id="{6246ACD0-BE8A-3D4B-8E89-B0E6ACFF594E}" type="slidenum">
-              <a:rPr lang="en-US" smtClean="0"/>
-              <a:t>12</a:t>
-            </a:fld>
-            <a:endParaRPr lang="en-US"/>
-          </a:p>
-        </p:txBody>
-      </p:sp>
-    </p:spTree>
-    <p:extLst>
-      <p:ext uri="{BB962C8B-B14F-4D97-AF65-F5344CB8AC3E}">
-        <p14:creationId xmlns:p14="http://schemas.microsoft.com/office/powerpoint/2010/main" val="2685218292"/>
       </p:ext>
     </p:extLst>
   </p:cSld>
@@ -9150,6 +9067,20 @@
             </a:pPr>
             <a:r>
               <a:rPr lang="en-AU" dirty="0"/>
+              <a:t>Open GitHub Desktop</a:t>
+            </a:r>
+          </a:p>
+          <a:p>
+            <a:pPr marL="457200" indent="-457200">
+              <a:lnSpc>
+                <a:spcPct val="100000"/>
+              </a:lnSpc>
+              <a:buBlip>
+                <a:blip r:embed="rId2"/>
+              </a:buBlip>
+            </a:pPr>
+            <a:r>
+              <a:rPr lang="en-AU" dirty="0"/>
               <a:t>Select File </a:t>
             </a:r>
             <a:r>
@@ -9264,7 +9195,7 @@
         </p:blipFill>
         <p:spPr>
           <a:xfrm>
-            <a:off x="4269442" y="3995943"/>
+            <a:off x="4269442" y="4546952"/>
             <a:ext cx="2716305" cy="2205620"/>
           </a:xfrm>
           <a:prstGeom prst="rect">
@@ -9342,7 +9273,7 @@
                   <a:schemeClr val="accent6"/>
                 </a:solidFill>
               </a:rPr>
-              <a:t>Cloning a new repository</a:t>
+              <a:t>Cloning a repository</a:t>
             </a:r>
           </a:p>
         </p:txBody>
@@ -9366,7 +9297,7 @@
         <p:spPr>
           <a:xfrm>
             <a:off x="0" y="972913"/>
-            <a:ext cx="6985747" cy="5885087"/>
+            <a:ext cx="11353800" cy="5885087"/>
           </a:xfrm>
         </p:spPr>
         <p:txBody>
@@ -9385,13 +9316,7 @@
             </a:pPr>
             <a:r>
               <a:rPr lang="en-AU" dirty="0"/>
-              <a:t>Select File </a:t>
-            </a:r>
-            <a:r>
-              <a:rPr lang="en-AU" dirty="0">
-                <a:sym typeface="Wingdings" pitchFamily="2" charset="2"/>
-              </a:rPr>
-              <a:t> New Repository</a:t>
+              <a:t>Go to GitHub website and check your repository is published</a:t>
             </a:r>
           </a:p>
           <a:p>
@@ -9407,7 +9332,81 @@
               <a:rPr lang="en-AU" dirty="0">
                 <a:sym typeface="Wingdings" pitchFamily="2" charset="2"/>
               </a:rPr>
-              <a:t>Enter the name, location you want to save the repository, a description, and tick “Initialize this repository with a README”</a:t>
+              <a:t>We will now clone my repository that you will use for weekly resources</a:t>
+            </a:r>
+          </a:p>
+          <a:p>
+            <a:pPr marL="687600" lvl="1" indent="-457200">
+              <a:lnSpc>
+                <a:spcPct val="100000"/>
+              </a:lnSpc>
+              <a:buBlip>
+                <a:blip r:embed="rId2"/>
+              </a:buBlip>
+            </a:pPr>
+            <a:r>
+              <a:rPr lang="en-AU" dirty="0">
+                <a:sym typeface="Wingdings" pitchFamily="2" charset="2"/>
+              </a:rPr>
+              <a:t>Copy this link: </a:t>
+            </a:r>
+            <a:r>
+              <a:rPr lang="en-AU" dirty="0">
+                <a:sym typeface="Wingdings" pitchFamily="2" charset="2"/>
+                <a:hlinkClick r:id="rId3"/>
+              </a:rPr>
+              <a:t>https://github.com/mithebell/PHYS3116_2026T3.git</a:t>
+            </a:r>
+            <a:endParaRPr lang="en-AU" dirty="0">
+              <a:sym typeface="Wingdings" pitchFamily="2" charset="2"/>
+            </a:endParaRPr>
+          </a:p>
+          <a:p>
+            <a:pPr marL="687600" lvl="1" indent="-457200">
+              <a:lnSpc>
+                <a:spcPct val="100000"/>
+              </a:lnSpc>
+              <a:buBlip>
+                <a:blip r:embed="rId2"/>
+              </a:buBlip>
+            </a:pPr>
+            <a:r>
+              <a:rPr lang="en-AU" dirty="0">
+                <a:sym typeface="Wingdings" pitchFamily="2" charset="2"/>
+              </a:rPr>
+              <a:t>Go back to GitHub Desktop</a:t>
+            </a:r>
+          </a:p>
+          <a:p>
+            <a:pPr marL="687600" lvl="1" indent="-457200">
+              <a:lnSpc>
+                <a:spcPct val="100000"/>
+              </a:lnSpc>
+              <a:buBlip>
+                <a:blip r:embed="rId2"/>
+              </a:buBlip>
+            </a:pPr>
+            <a:r>
+              <a:rPr lang="en-AU" dirty="0">
+                <a:sym typeface="Wingdings" pitchFamily="2" charset="2"/>
+              </a:rPr>
+              <a:t>File  Clone Repository  URL</a:t>
+            </a:r>
+          </a:p>
+          <a:p>
+            <a:pPr marL="687600" lvl="1" indent="-457200">
+              <a:lnSpc>
+                <a:spcPct val="100000"/>
+              </a:lnSpc>
+              <a:buBlip>
+                <a:blip r:embed="rId2"/>
+              </a:buBlip>
+            </a:pPr>
+            <a:r>
+              <a:rPr lang="en-AU" dirty="0">
+                <a:sym typeface="Wingdings" pitchFamily="2" charset="2"/>
+              </a:rPr>
+              <a:t>Paste in the link and clone</a:t>
             </a:r>
           </a:p>
           <a:p>
@@ -9423,18 +9422,17 @@
               <a:rPr lang="en-AU" dirty="0">
                 <a:sym typeface="Wingdings" pitchFamily="2" charset="2"/>
               </a:rPr>
-              <a:t>Check that the file now exists locally on your laptop</a:t>
-            </a:r>
-            <a:endParaRPr lang="en-AU" dirty="0"/>
+              <a:t>To push or</a:t>
+            </a:r>
           </a:p>
         </p:txBody>
       </p:sp>
       <p:pic>
         <p:nvPicPr>
-          <p:cNvPr id="7" name="Picture 6">
-            <a:extLst>
-              <a:ext uri="{FF2B5EF4-FFF2-40B4-BE49-F238E27FC236}">
-                <a16:creationId xmlns:a16="http://schemas.microsoft.com/office/drawing/2014/main" id="{B1AE3CA3-F64E-CCEE-0EDA-DB03021550FA}"/>
+          <p:cNvPr id="5" name="Picture 4">
+            <a:extLst>
+              <a:ext uri="{FF2B5EF4-FFF2-40B4-BE49-F238E27FC236}">
+                <a16:creationId xmlns:a16="http://schemas.microsoft.com/office/drawing/2014/main" id="{B76D1947-782B-240B-180C-1E45FB7BE636}"/>
               </a:ext>
             </a:extLst>
           </p:cNvPr>
@@ -9444,16 +9442,15 @@
           <p:nvPr/>
         </p:nvPicPr>
         <p:blipFill>
-          <a:blip r:embed="rId3"/>
-          <a:srcRect l="3887" t="3013" r="2202" b="2224"/>
+          <a:blip r:embed="rId4"/>
           <a:stretch>
             <a:fillRect/>
           </a:stretch>
         </p:blipFill>
         <p:spPr>
           <a:xfrm>
-            <a:off x="6985747" y="1161173"/>
-            <a:ext cx="4065494" cy="5040390"/>
+            <a:off x="5676900" y="3351703"/>
+            <a:ext cx="5463241" cy="3145842"/>
           </a:xfrm>
           <a:prstGeom prst="rect">
             <a:avLst/>
@@ -9481,7 +9478,7 @@
         <p:cNvPr id="1" name="">
           <a:extLst>
             <a:ext uri="{FF2B5EF4-FFF2-40B4-BE49-F238E27FC236}">
-              <a16:creationId xmlns:a16="http://schemas.microsoft.com/office/drawing/2014/main" id="{703904CB-DFEA-A8A1-CC28-6E8C86F9B518}"/>
+              <a16:creationId xmlns:a16="http://schemas.microsoft.com/office/drawing/2014/main" id="{7DAD99B8-9885-CC79-9E5F-F2BE36CBCBD5}"/>
             </a:ext>
           </a:extLst>
         </p:cNvPr>
@@ -9501,7 +9498,7 @@
           <p:cNvPr id="2" name="Title 1">
             <a:extLst>
               <a:ext uri="{FF2B5EF4-FFF2-40B4-BE49-F238E27FC236}">
-                <a16:creationId xmlns:a16="http://schemas.microsoft.com/office/drawing/2014/main" id="{E9595744-42CF-2E0F-7457-265277295D50}"/>
+                <a16:creationId xmlns:a16="http://schemas.microsoft.com/office/drawing/2014/main" id="{817B1C9C-573C-0AE3-B9AD-5555AEB32834}"/>
               </a:ext>
             </a:extLst>
           </p:cNvPr>
@@ -9530,7 +9527,7 @@
                   <a:schemeClr val="accent6"/>
                 </a:solidFill>
               </a:rPr>
-              <a:t>Setting up GitHub</a:t>
+              <a:t>Making a new Python file</a:t>
             </a:r>
           </a:p>
         </p:txBody>
@@ -9540,7 +9537,7 @@
           <p:cNvPr id="3" name="Content Placeholder 2">
             <a:extLst>
               <a:ext uri="{FF2B5EF4-FFF2-40B4-BE49-F238E27FC236}">
-                <a16:creationId xmlns:a16="http://schemas.microsoft.com/office/drawing/2014/main" id="{708346CF-A41F-4B9D-DBD1-0B2C2C7DFDE5}"/>
+                <a16:creationId xmlns:a16="http://schemas.microsoft.com/office/drawing/2014/main" id="{A92B8CE1-9623-9A3E-5920-89A7A94FD605}"/>
               </a:ext>
             </a:extLst>
           </p:cNvPr>
@@ -9563,16 +9560,45 @@
           </a:bodyPr>
           <a:lstStyle/>
           <a:p>
+            <a:pPr marL="457200" indent="-457200">
+              <a:lnSpc>
+                <a:spcPct val="100000"/>
+              </a:lnSpc>
+              <a:buBlip>
+                <a:blip r:embed="rId2"/>
+              </a:buBlip>
+            </a:pPr>
+            <a:r>
+              <a:rPr lang="en-AU" dirty="0"/>
+              <a:t>Open VS Code</a:t>
+            </a:r>
+          </a:p>
+          <a:p>
+            <a:pPr marL="457200" indent="-457200">
+              <a:lnSpc>
+                <a:spcPct val="100000"/>
+              </a:lnSpc>
+              <a:buBlip>
+                <a:blip r:embed="rId2"/>
+              </a:buBlip>
+            </a:pPr>
+            <a:r>
+              <a:rPr lang="en-AU" dirty="0"/>
+              <a:t>At the top search bar type in: &gt;Python: Select Interpreter</a:t>
+            </a:r>
+          </a:p>
+          <a:p>
             <a:pPr marL="687600" lvl="1" indent="-457200">
               <a:lnSpc>
                 <a:spcPct val="100000"/>
               </a:lnSpc>
-              <a:buFont typeface="+mj-lt"/>
-              <a:buAutoNum type="arabicPeriod" startAt="3"/>
+              <a:buBlip>
+                <a:blip r:embed="rId2"/>
+              </a:buBlip>
             </a:pPr>
             <a:r>
               <a:rPr lang="en-AU" dirty="0"/>
-              <a:t>Check that you have your repository on your profile</a:t>
+              <a:t>Choose the base environment from miniconda3 (it should have Conda next to it)</a:t>
             </a:r>
           </a:p>
           <a:p>
@@ -9580,28 +9606,9 @@
               <a:lnSpc>
                 <a:spcPct val="100000"/>
               </a:lnSpc>
-              <a:buFont typeface="+mj-lt"/>
-              <a:buAutoNum type="arabicPeriod" startAt="3"/>
-            </a:pPr>
-            <a:endParaRPr lang="en-AU" dirty="0"/>
-          </a:p>
-          <a:p>
-            <a:pPr marL="687600" lvl="1" indent="-457200">
-              <a:lnSpc>
-                <a:spcPct val="100000"/>
-              </a:lnSpc>
-              <a:buFont typeface="+mj-lt"/>
-              <a:buAutoNum type="arabicPeriod" startAt="3"/>
-            </a:pPr>
-            <a:endParaRPr lang="en-AU" dirty="0"/>
-          </a:p>
-          <a:p>
-            <a:pPr marL="687600" lvl="1" indent="-457200">
-              <a:lnSpc>
-                <a:spcPct val="100000"/>
-              </a:lnSpc>
-              <a:buFont typeface="+mj-lt"/>
-              <a:buAutoNum type="arabicPeriod" startAt="3"/>
+              <a:buBlip>
+                <a:blip r:embed="rId2"/>
+              </a:buBlip>
             </a:pPr>
             <a:endParaRPr lang="en-AU" dirty="0"/>
           </a:p>
@@ -9615,109 +9622,78 @@
             <a:endParaRPr lang="en-AU" dirty="0"/>
           </a:p>
           <a:p>
-            <a:pPr marL="687600" lvl="1" indent="-457200">
+            <a:pPr lvl="1" indent="0">
               <a:lnSpc>
                 <a:spcPct val="100000"/>
               </a:lnSpc>
-              <a:buFont typeface="+mj-lt"/>
-              <a:buAutoNum type="arabicPeriod" startAt="4"/>
+              <a:buNone/>
             </a:pPr>
-            <a:r>
-              <a:rPr lang="en-AU" dirty="0"/>
-              <a:t>Return to VS Code, and type </a:t>
-            </a:r>
-            <a:r>
-              <a:rPr lang="en-AU" b="1" dirty="0">
-                <a:solidFill>
-                  <a:schemeClr val="accent3"/>
-                </a:solidFill>
-              </a:rPr>
-              <a:t>&gt;Git: Clone </a:t>
-            </a:r>
-            <a:r>
-              <a:rPr lang="en-AU" dirty="0"/>
-              <a:t>in the Command Palette</a:t>
-            </a:r>
-            <a:br>
-              <a:rPr lang="en-AU" dirty="0"/>
-            </a:br>
-            <a:br>
-              <a:rPr lang="en-AU" dirty="0"/>
-            </a:br>
-            <a:endParaRPr lang="en-AU" dirty="0">
-              <a:solidFill>
-                <a:schemeClr val="accent5"/>
-              </a:solidFill>
-            </a:endParaRPr>
-          </a:p>
-          <a:p>
-            <a:pPr marL="687600" lvl="1" indent="-457200">
+            <a:endParaRPr lang="en-AU" dirty="0"/>
+          </a:p>
+          <a:p>
+            <a:pPr marL="457200" indent="-457200">
               <a:lnSpc>
                 <a:spcPct val="100000"/>
               </a:lnSpc>
-              <a:buFont typeface="+mj-lt"/>
-              <a:buAutoNum type="arabicPeriod" startAt="4"/>
+              <a:buBlip>
+                <a:blip r:embed="rId2"/>
+              </a:buBlip>
             </a:pPr>
             <a:r>
-              <a:rPr lang="en-AU" dirty="0"/>
-              <a:t>Choose Clone from GitHub, and select the repository you want to clone</a:t>
-            </a:r>
-          </a:p>
-          <a:p>
-            <a:pPr marL="687600" lvl="1" indent="-457200">
+              <a:rPr lang="en-AU" dirty="0">
+                <a:sym typeface="Wingdings" pitchFamily="2" charset="2"/>
+              </a:rPr>
+              <a:t>File  New File  Python File/Jupyter Notebook</a:t>
+            </a:r>
+          </a:p>
+          <a:p>
+            <a:pPr marL="457200" indent="-457200">
               <a:lnSpc>
                 <a:spcPct val="100000"/>
               </a:lnSpc>
-              <a:buFont typeface="+mj-lt"/>
-              <a:buAutoNum type="arabicPeriod" startAt="4"/>
+              <a:buBlip>
+                <a:blip r:embed="rId2"/>
+              </a:buBlip>
             </a:pPr>
             <a:r>
-              <a:rPr lang="en-AU" dirty="0"/>
-              <a:t>Make a new folder where you want to keep your code and select it as the repository destination</a:t>
-            </a:r>
-          </a:p>
-          <a:p>
-            <a:pPr marL="687600" lvl="1" indent="-457200">
+              <a:rPr lang="en-AU" dirty="0">
+                <a:sym typeface="Wingdings" pitchFamily="2" charset="2"/>
+              </a:rPr>
+              <a:t>Save Python Script or Jupyter Notebook in YOUR repository</a:t>
+            </a:r>
+          </a:p>
+          <a:p>
+            <a:pPr marL="457200" indent="-457200">
               <a:lnSpc>
                 <a:spcPct val="100000"/>
               </a:lnSpc>
-              <a:buFont typeface="+mj-lt"/>
-              <a:buAutoNum type="arabicPeriod" startAt="4"/>
+              <a:buBlip>
+                <a:blip r:embed="rId2"/>
+              </a:buBlip>
             </a:pPr>
-            <a:r>
-              <a:rPr lang="en-AU" dirty="0"/>
-              <a:t>Go back to the Command Palette and type </a:t>
-            </a:r>
-            <a:r>
-              <a:rPr lang="en-AU" b="1" dirty="0">
-                <a:solidFill>
-                  <a:schemeClr val="accent3"/>
-                </a:solidFill>
-              </a:rPr>
-              <a:t>&gt;Git: Initialize Repository</a:t>
-            </a:r>
-          </a:p>
-          <a:p>
-            <a:pPr marL="687600" lvl="1" indent="-457200">
+            <a:endParaRPr lang="en-AU" dirty="0">
+              <a:sym typeface="Wingdings" pitchFamily="2" charset="2"/>
+            </a:endParaRPr>
+          </a:p>
+          <a:p>
+            <a:pPr marL="457200" indent="-457200">
               <a:lnSpc>
                 <a:spcPct val="100000"/>
               </a:lnSpc>
-              <a:buFont typeface="+mj-lt"/>
-              <a:buAutoNum type="arabicPeriod" startAt="4"/>
+              <a:buBlip>
+                <a:blip r:embed="rId2"/>
+              </a:buBlip>
             </a:pPr>
-            <a:r>
-              <a:rPr lang="en-AU" dirty="0"/>
-              <a:t>You can now start committing to GitHub</a:t>
-            </a:r>
+            <a:endParaRPr lang="en-AU" dirty="0"/>
           </a:p>
         </p:txBody>
       </p:sp>
       <p:pic>
         <p:nvPicPr>
-          <p:cNvPr id="5" name="Picture 4" descr="A screenshot of a computer&#10;&#10;AI-generated content may be incorrect.">
-            <a:extLst>
-              <a:ext uri="{FF2B5EF4-FFF2-40B4-BE49-F238E27FC236}">
-                <a16:creationId xmlns:a16="http://schemas.microsoft.com/office/drawing/2014/main" id="{5F58A7A6-573A-A902-D7CB-C587AAD26186}"/>
+          <p:cNvPr id="6" name="Picture 5">
+            <a:extLst>
+              <a:ext uri="{FF2B5EF4-FFF2-40B4-BE49-F238E27FC236}">
+                <a16:creationId xmlns:a16="http://schemas.microsoft.com/office/drawing/2014/main" id="{608DB3B2-98D2-5A74-75FF-079C01F06C12}"/>
               </a:ext>
             </a:extLst>
           </p:cNvPr>
@@ -9728,44 +9704,15 @@
         </p:nvPicPr>
         <p:blipFill>
           <a:blip r:embed="rId3"/>
+          <a:srcRect b="42963"/>
           <a:stretch>
             <a:fillRect/>
           </a:stretch>
         </p:blipFill>
         <p:spPr>
           <a:xfrm>
-            <a:off x="2200563" y="1523050"/>
-            <a:ext cx="7790873" cy="1675943"/>
-          </a:xfrm>
-          <a:prstGeom prst="rect">
-            <a:avLst/>
-          </a:prstGeom>
-        </p:spPr>
-      </p:pic>
-      <p:pic>
-        <p:nvPicPr>
-          <p:cNvPr id="8" name="Picture 7">
-            <a:extLst>
-              <a:ext uri="{FF2B5EF4-FFF2-40B4-BE49-F238E27FC236}">
-                <a16:creationId xmlns:a16="http://schemas.microsoft.com/office/drawing/2014/main" id="{7D02DE4A-4A04-90C0-F6F3-859989B43869}"/>
-              </a:ext>
-            </a:extLst>
-          </p:cNvPr>
-          <p:cNvPicPr>
-            <a:picLocks noChangeAspect="1"/>
-          </p:cNvPicPr>
-          <p:nvPr/>
-        </p:nvPicPr>
-        <p:blipFill>
-          <a:blip r:embed="rId4"/>
-          <a:stretch>
-            <a:fillRect/>
-          </a:stretch>
-        </p:blipFill>
-        <p:spPr>
-          <a:xfrm>
-            <a:off x="2945682" y="3719634"/>
-            <a:ext cx="6300635" cy="675720"/>
+            <a:off x="3378200" y="2923988"/>
+            <a:ext cx="4597400" cy="1144494"/>
           </a:xfrm>
           <a:prstGeom prst="rect">
             <a:avLst/>
@@ -9775,7 +9722,7 @@
     </p:spTree>
     <p:extLst>
       <p:ext uri="{BB962C8B-B14F-4D97-AF65-F5344CB8AC3E}">
-        <p14:creationId xmlns:p14="http://schemas.microsoft.com/office/powerpoint/2010/main" val="2643955523"/>
+        <p14:creationId xmlns:p14="http://schemas.microsoft.com/office/powerpoint/2010/main" val="1215298339"/>
       </p:ext>
     </p:extLst>
   </p:cSld>
@@ -9793,7 +9740,7 @@
         <p:cNvPr id="1" name="">
           <a:extLst>
             <a:ext uri="{FF2B5EF4-FFF2-40B4-BE49-F238E27FC236}">
-              <a16:creationId xmlns:a16="http://schemas.microsoft.com/office/drawing/2014/main" id="{A869A679-5532-6D09-8080-E2117D7FD758}"/>
+              <a16:creationId xmlns:a16="http://schemas.microsoft.com/office/drawing/2014/main" id="{F16A2750-1D57-68F1-BDA7-B71BE9605940}"/>
             </a:ext>
           </a:extLst>
         </p:cNvPr>
@@ -9813,7 +9760,7 @@
           <p:cNvPr id="2" name="Title 1">
             <a:extLst>
               <a:ext uri="{FF2B5EF4-FFF2-40B4-BE49-F238E27FC236}">
-                <a16:creationId xmlns:a16="http://schemas.microsoft.com/office/drawing/2014/main" id="{3EAEBC41-EEE2-D68E-9D3A-ABCCD3EA9A58}"/>
+                <a16:creationId xmlns:a16="http://schemas.microsoft.com/office/drawing/2014/main" id="{16D5A6DF-D482-A871-D528-155928BA32D1}"/>
               </a:ext>
             </a:extLst>
           </p:cNvPr>
@@ -9842,7 +9789,7 @@
                   <a:schemeClr val="accent6"/>
                 </a:solidFill>
               </a:rPr>
-              <a:t>Setting up GitHub</a:t>
+              <a:t>Committing to GitHub</a:t>
             </a:r>
           </a:p>
         </p:txBody>
@@ -9852,7 +9799,7 @@
           <p:cNvPr id="3" name="Content Placeholder 2">
             <a:extLst>
               <a:ext uri="{FF2B5EF4-FFF2-40B4-BE49-F238E27FC236}">
-                <a16:creationId xmlns:a16="http://schemas.microsoft.com/office/drawing/2014/main" id="{AD2161C4-BEC0-D094-E4B9-D27F95554548}"/>
+                <a16:creationId xmlns:a16="http://schemas.microsoft.com/office/drawing/2014/main" id="{ED54229D-BD22-4908-05F9-C7C071C9FD75}"/>
               </a:ext>
             </a:extLst>
           </p:cNvPr>
@@ -9885,7 +9832,41 @@
             </a:pPr>
             <a:r>
               <a:rPr lang="en-AU" dirty="0"/>
-              <a:t>Staging and committing code</a:t>
+              <a:t>Open GitHub Desktop</a:t>
+            </a:r>
+          </a:p>
+          <a:p>
+            <a:pPr marL="457200" indent="-457200">
+              <a:lnSpc>
+                <a:spcPct val="100000"/>
+              </a:lnSpc>
+              <a:buBlip>
+                <a:blip r:embed="rId2"/>
+              </a:buBlip>
+            </a:pPr>
+            <a:r>
+              <a:rPr lang="en-AU" dirty="0"/>
+              <a:t>Your new change should have shown up as a changed file</a:t>
+            </a:r>
+          </a:p>
+          <a:p>
+            <a:pPr marL="457200" indent="-457200">
+              <a:lnSpc>
+                <a:spcPct val="100000"/>
+              </a:lnSpc>
+              <a:buBlip>
+                <a:blip r:embed="rId2"/>
+              </a:buBlip>
+            </a:pPr>
+            <a:r>
+              <a:rPr lang="en-AU" dirty="0"/>
+              <a:t>Tick the change you want to commit </a:t>
+            </a:r>
+            <a:r>
+              <a:rPr lang="en-AU" dirty="0">
+                <a:sym typeface="Wingdings" pitchFamily="2" charset="2"/>
+              </a:rPr>
+              <a:t> Commit to main</a:t>
             </a:r>
           </a:p>
           <a:p>
@@ -9894,12 +9875,14 @@
                 <a:spcPct val="100000"/>
               </a:lnSpc>
               <a:buBlip>
-                <a:blip r:embed="rId3"/>
+                <a:blip r:embed="rId2"/>
               </a:buBlip>
             </a:pPr>
             <a:r>
-              <a:rPr lang="en-AU" dirty="0"/>
-              <a:t>Go to Source Control</a:t>
+              <a:rPr lang="en-AU" dirty="0">
+                <a:sym typeface="Wingdings" pitchFamily="2" charset="2"/>
+              </a:rPr>
+              <a:t>Here main means you are on the main branch</a:t>
             </a:r>
           </a:p>
           <a:p>
@@ -9908,213 +9891,33 @@
                 <a:spcPct val="100000"/>
               </a:lnSpc>
               <a:buBlip>
-                <a:blip r:embed="rId3"/>
+                <a:blip r:embed="rId2"/>
               </a:buBlip>
             </a:pPr>
             <a:r>
-              <a:rPr lang="en-AU" dirty="0"/>
-              <a:t>Add the changes you want to commit, and press commit</a:t>
-            </a:r>
-          </a:p>
-          <a:p>
-            <a:pPr marL="687600" lvl="1" indent="-457200">
+              <a:rPr lang="en-AU" dirty="0">
+                <a:sym typeface="Wingdings" pitchFamily="2" charset="2"/>
+              </a:rPr>
+              <a:t>Branching and forking is not required for this course</a:t>
+            </a:r>
+          </a:p>
+          <a:p>
+            <a:pPr marL="457200" indent="-457200">
               <a:lnSpc>
                 <a:spcPct val="100000"/>
               </a:lnSpc>
               <a:buBlip>
-                <a:blip r:embed="rId3"/>
+                <a:blip r:embed="rId2"/>
               </a:buBlip>
             </a:pPr>
             <a:endParaRPr lang="en-AU" dirty="0"/>
           </a:p>
-          <a:p>
-            <a:pPr marL="687600" lvl="1" indent="-457200">
-              <a:lnSpc>
-                <a:spcPct val="100000"/>
-              </a:lnSpc>
-              <a:buBlip>
-                <a:blip r:embed="rId3"/>
-              </a:buBlip>
-            </a:pPr>
-            <a:endParaRPr lang="en-AU" dirty="0"/>
-          </a:p>
-          <a:p>
-            <a:pPr marL="687600" lvl="1" indent="-457200">
-              <a:lnSpc>
-                <a:spcPct val="100000"/>
-              </a:lnSpc>
-              <a:buBlip>
-                <a:blip r:embed="rId3"/>
-              </a:buBlip>
-            </a:pPr>
-            <a:endParaRPr lang="en-AU" dirty="0"/>
-          </a:p>
-          <a:p>
-            <a:pPr marL="687600" lvl="1" indent="-457200">
-              <a:lnSpc>
-                <a:spcPct val="100000"/>
-              </a:lnSpc>
-              <a:buBlip>
-                <a:blip r:embed="rId3"/>
-              </a:buBlip>
-            </a:pPr>
-            <a:endParaRPr lang="en-AU" dirty="0"/>
-          </a:p>
-          <a:p>
-            <a:pPr lvl="1" indent="0">
-              <a:lnSpc>
-                <a:spcPct val="100000"/>
-              </a:lnSpc>
-              <a:buNone/>
-            </a:pPr>
-            <a:endParaRPr lang="en-AU" dirty="0"/>
-          </a:p>
-          <a:p>
-            <a:pPr marL="687600" lvl="1" indent="-457200">
-              <a:lnSpc>
-                <a:spcPct val="100000"/>
-              </a:lnSpc>
-              <a:buBlip>
-                <a:blip r:embed="rId3"/>
-              </a:buBlip>
-            </a:pPr>
-            <a:r>
-              <a:rPr lang="en-AU" dirty="0"/>
-              <a:t>Write a short description of what you are committing and press the tick in the upper right corner</a:t>
-            </a:r>
-          </a:p>
-          <a:p>
-            <a:pPr marL="687600" lvl="1" indent="-457200">
-              <a:lnSpc>
-                <a:spcPct val="100000"/>
-              </a:lnSpc>
-              <a:buBlip>
-                <a:blip r:embed="rId3"/>
-              </a:buBlip>
-            </a:pPr>
-            <a:endParaRPr lang="en-AU" dirty="0"/>
-          </a:p>
-        </p:txBody>
-      </p:sp>
-      <p:pic>
-        <p:nvPicPr>
-          <p:cNvPr id="9" name="Picture 8" descr="A screenshot of a computer&#10;&#10;AI-generated content may be incorrect.">
-            <a:extLst>
-              <a:ext uri="{FF2B5EF4-FFF2-40B4-BE49-F238E27FC236}">
-                <a16:creationId xmlns:a16="http://schemas.microsoft.com/office/drawing/2014/main" id="{F7067B10-C3AB-D24A-52E9-23B8DFAEB614}"/>
-              </a:ext>
-            </a:extLst>
-          </p:cNvPr>
-          <p:cNvPicPr>
-            <a:picLocks noChangeAspect="1"/>
-          </p:cNvPicPr>
-          <p:nvPr/>
-        </p:nvPicPr>
-        <p:blipFill>
-          <a:blip r:embed="rId4"/>
-          <a:stretch>
-            <a:fillRect/>
-          </a:stretch>
-        </p:blipFill>
-        <p:spPr>
-          <a:xfrm>
-            <a:off x="3814041" y="2609457"/>
-            <a:ext cx="4563918" cy="1833049"/>
-          </a:xfrm>
-          <a:prstGeom prst="rect">
-            <a:avLst/>
-          </a:prstGeom>
-        </p:spPr>
-      </p:pic>
-      <p:pic>
-        <p:nvPicPr>
-          <p:cNvPr id="11" name="Picture 10" descr="A blue rectangular object with a black border&#10;&#10;AI-generated content may be incorrect.">
-            <a:extLst>
-              <a:ext uri="{FF2B5EF4-FFF2-40B4-BE49-F238E27FC236}">
-                <a16:creationId xmlns:a16="http://schemas.microsoft.com/office/drawing/2014/main" id="{E3396CF0-44D5-E266-995E-2DF2222CD7FC}"/>
-              </a:ext>
-            </a:extLst>
-          </p:cNvPr>
-          <p:cNvPicPr>
-            <a:picLocks noChangeAspect="1"/>
-          </p:cNvPicPr>
-          <p:nvPr/>
-        </p:nvPicPr>
-        <p:blipFill>
-          <a:blip r:embed="rId5"/>
-          <a:srcRect b="50000"/>
-          <a:stretch>
-            <a:fillRect/>
-          </a:stretch>
-        </p:blipFill>
-        <p:spPr>
-          <a:xfrm>
-            <a:off x="1193800" y="5671525"/>
-            <a:ext cx="9804400" cy="815050"/>
-          </a:xfrm>
-          <a:prstGeom prst="rect">
-            <a:avLst/>
-          </a:prstGeom>
-        </p:spPr>
-      </p:pic>
-      <p:sp>
-        <p:nvSpPr>
-          <p:cNvPr id="12" name="Oval 11">
-            <a:extLst>
-              <a:ext uri="{FF2B5EF4-FFF2-40B4-BE49-F238E27FC236}">
-                <a16:creationId xmlns:a16="http://schemas.microsoft.com/office/drawing/2014/main" id="{98C01C7C-A449-F2E5-F80C-EC746B12ADDE}"/>
-              </a:ext>
-            </a:extLst>
-          </p:cNvPr>
-          <p:cNvSpPr>
-            <a:spLocks noChangeAspect="1"/>
-          </p:cNvSpPr>
-          <p:nvPr/>
-        </p:nvSpPr>
-        <p:spPr>
-          <a:xfrm>
-            <a:off x="10300609" y="5613132"/>
-            <a:ext cx="360000" cy="360000"/>
-          </a:xfrm>
-          <a:prstGeom prst="ellipse">
-            <a:avLst/>
-          </a:prstGeom>
-          <a:noFill/>
-          <a:ln w="38100">
-            <a:solidFill>
-              <a:schemeClr val="accent6"/>
-            </a:solidFill>
-          </a:ln>
-        </p:spPr>
-        <p:style>
-          <a:lnRef idx="2">
-            <a:schemeClr val="accent1">
-              <a:shade val="15000"/>
-            </a:schemeClr>
-          </a:lnRef>
-          <a:fillRef idx="1">
-            <a:schemeClr val="accent1"/>
-          </a:fillRef>
-          <a:effectRef idx="0">
-            <a:schemeClr val="accent1"/>
-          </a:effectRef>
-          <a:fontRef idx="minor">
-            <a:schemeClr val="lt1"/>
-          </a:fontRef>
-        </p:style>
-        <p:txBody>
-          <a:bodyPr rtlCol="0" anchor="ctr"/>
-          <a:lstStyle/>
-          <a:p>
-            <a:pPr algn="ctr"/>
-            <a:endParaRPr lang="en-AU"/>
-          </a:p>
         </p:txBody>
       </p:sp>
     </p:spTree>
     <p:extLst>
       <p:ext uri="{BB962C8B-B14F-4D97-AF65-F5344CB8AC3E}">
-        <p14:creationId xmlns:p14="http://schemas.microsoft.com/office/powerpoint/2010/main" val="2470904406"/>
+        <p14:creationId xmlns:p14="http://schemas.microsoft.com/office/powerpoint/2010/main" val="1711097694"/>
       </p:ext>
     </p:extLst>
   </p:cSld>
@@ -10132,7 +9935,7 @@
         <p:cNvPr id="1" name="">
           <a:extLst>
             <a:ext uri="{FF2B5EF4-FFF2-40B4-BE49-F238E27FC236}">
-              <a16:creationId xmlns:a16="http://schemas.microsoft.com/office/drawing/2014/main" id="{FBF5AD80-0EC2-B462-581C-FD3E64022BA9}"/>
+              <a16:creationId xmlns:a16="http://schemas.microsoft.com/office/drawing/2014/main" id="{309491BE-4067-ADC4-516C-DC23CD43A2E0}"/>
             </a:ext>
           </a:extLst>
         </p:cNvPr>
@@ -10152,7 +9955,7 @@
           <p:cNvPr id="2" name="Title 1">
             <a:extLst>
               <a:ext uri="{FF2B5EF4-FFF2-40B4-BE49-F238E27FC236}">
-                <a16:creationId xmlns:a16="http://schemas.microsoft.com/office/drawing/2014/main" id="{E746FE66-11BC-5A3D-6ED3-9BE451603DC8}"/>
+                <a16:creationId xmlns:a16="http://schemas.microsoft.com/office/drawing/2014/main" id="{83C3C550-8113-C99D-251C-32365EB3CB4A}"/>
               </a:ext>
             </a:extLst>
           </p:cNvPr>
@@ -10181,7 +9984,7 @@
                   <a:schemeClr val="accent6"/>
                 </a:solidFill>
               </a:rPr>
-              <a:t>Setting up GitHub</a:t>
+              <a:t>Working collaboratively on GitHub</a:t>
             </a:r>
           </a:p>
         </p:txBody>
@@ -10191,7 +9994,7 @@
           <p:cNvPr id="3" name="Content Placeholder 2">
             <a:extLst>
               <a:ext uri="{FF2B5EF4-FFF2-40B4-BE49-F238E27FC236}">
-                <a16:creationId xmlns:a16="http://schemas.microsoft.com/office/drawing/2014/main" id="{AEC25CE5-C54F-1180-41F7-5035C4D8D8DC}"/>
+                <a16:creationId xmlns:a16="http://schemas.microsoft.com/office/drawing/2014/main" id="{63647A7C-7A02-EA17-61E9-81030D79EB75}"/>
               </a:ext>
             </a:extLst>
           </p:cNvPr>
@@ -10224,21 +10027,7 @@
             </a:pPr>
             <a:r>
               <a:rPr lang="en-AU" dirty="0"/>
-              <a:t>Staging and committing code</a:t>
-            </a:r>
-          </a:p>
-          <a:p>
-            <a:pPr marL="687600" lvl="1" indent="-457200">
-              <a:lnSpc>
-                <a:spcPct val="100000"/>
-              </a:lnSpc>
-              <a:buBlip>
-                <a:blip r:embed="rId3"/>
-              </a:buBlip>
-            </a:pPr>
-            <a:r>
-              <a:rPr lang="en-AU" dirty="0"/>
-              <a:t>Sync your changes and check you have your new code/files on GitHub</a:t>
+              <a:t>Have one shared GitHub repository for each group</a:t>
             </a:r>
           </a:p>
           <a:p>
@@ -10252,35 +10041,7 @@
             </a:pPr>
             <a:r>
               <a:rPr lang="en-AU" dirty="0"/>
-              <a:t>Adding collaborators</a:t>
-            </a:r>
-          </a:p>
-          <a:p>
-            <a:pPr marL="687600" lvl="1" indent="-457200">
-              <a:lnSpc>
-                <a:spcPct val="100000"/>
-              </a:lnSpc>
-              <a:buBlip>
-                <a:blip r:embed="rId3"/>
-              </a:buBlip>
-            </a:pPr>
-            <a:r>
-              <a:rPr lang="en-AU" dirty="0"/>
-              <a:t>Go to the settings of your repository, and select Collaborators</a:t>
-            </a:r>
-          </a:p>
-          <a:p>
-            <a:pPr marL="687600" lvl="1" indent="-457200">
-              <a:lnSpc>
-                <a:spcPct val="100000"/>
-              </a:lnSpc>
-              <a:buBlip>
-                <a:blip r:embed="rId3"/>
-              </a:buBlip>
-            </a:pPr>
-            <a:r>
-              <a:rPr lang="en-AU" dirty="0"/>
-              <a:t>Invite your group mates</a:t>
+              <a:t>Clone GitHub Desktop onto your laptop</a:t>
             </a:r>
           </a:p>
           <a:p>
@@ -10294,7 +10055,57 @@
             </a:pPr>
             <a:r>
               <a:rPr lang="en-AU" dirty="0"/>
-              <a:t>Clone the repository for the other collaborators</a:t>
+              <a:t>At the start of every coding session:</a:t>
+            </a:r>
+          </a:p>
+          <a:p>
+            <a:pPr marL="687600" lvl="1" indent="-457200">
+              <a:lnSpc>
+                <a:spcPct val="100000"/>
+              </a:lnSpc>
+              <a:buBlip>
+                <a:blip r:embed="rId2"/>
+              </a:buBlip>
+            </a:pPr>
+            <a:r>
+              <a:rPr lang="en-AU" dirty="0"/>
+              <a:t>Go to GitHub Desktop</a:t>
+            </a:r>
+          </a:p>
+          <a:p>
+            <a:pPr marL="687600" lvl="1" indent="-457200">
+              <a:lnSpc>
+                <a:spcPct val="100000"/>
+              </a:lnSpc>
+              <a:buBlip>
+                <a:blip r:embed="rId2"/>
+              </a:buBlip>
+            </a:pPr>
+            <a:r>
+              <a:rPr lang="en-AU" dirty="0"/>
+              <a:t>Repository </a:t>
+            </a:r>
+            <a:r>
+              <a:rPr lang="en-AU" dirty="0">
+                <a:sym typeface="Wingdings" pitchFamily="2" charset="2"/>
+              </a:rPr>
+              <a:t> Pull</a:t>
+            </a:r>
+          </a:p>
+          <a:p>
+            <a:pPr marL="687600" lvl="1" indent="-457200">
+              <a:lnSpc>
+                <a:spcPct val="100000"/>
+              </a:lnSpc>
+              <a:buBlip>
+                <a:blip r:embed="rId2"/>
+              </a:buBlip>
+            </a:pPr>
+            <a:r>
+              <a:rPr lang="en-AU" dirty="0">
+                <a:sym typeface="Wingdings" pitchFamily="2" charset="2"/>
+              </a:rPr>
+              <a:t>Make sure your laptop is up to date with the latest version on GitHub</a:t>
             </a:r>
           </a:p>
           <a:p>
@@ -10307,8 +10118,10 @@
               </a:buBlip>
             </a:pPr>
             <a:r>
-              <a:rPr lang="en-AU" dirty="0"/>
-              <a:t>Be careful about changing the code at the same time</a:t>
+              <a:rPr lang="en-AU" dirty="0">
+                <a:sym typeface="Wingdings" pitchFamily="2" charset="2"/>
+              </a:rPr>
+              <a:t>At the end of every coding session:</a:t>
             </a:r>
           </a:p>
           <a:p>
@@ -10317,12 +10130,14 @@
                 <a:spcPct val="100000"/>
               </a:lnSpc>
               <a:buBlip>
-                <a:blip r:embed="rId3"/>
+                <a:blip r:embed="rId2"/>
               </a:buBlip>
             </a:pPr>
             <a:r>
-              <a:rPr lang="en-AU" dirty="0"/>
-              <a:t>I recommend communicating when code has been changed</a:t>
+              <a:rPr lang="en-AU" dirty="0">
+                <a:sym typeface="Wingdings" pitchFamily="2" charset="2"/>
+              </a:rPr>
+              <a:t>Commit and push to GitHub so your group members can see</a:t>
             </a:r>
           </a:p>
           <a:p>
@@ -10331,20 +10146,19 @@
                 <a:spcPct val="100000"/>
               </a:lnSpc>
               <a:buBlip>
-                <a:blip r:embed="rId3"/>
+                <a:blip r:embed="rId2"/>
               </a:buBlip>
             </a:pPr>
-            <a:r>
-              <a:rPr lang="en-AU" dirty="0"/>
-              <a:t>If you are advanced, use branches</a:t>
-            </a:r>
+            <a:endParaRPr lang="en-AU" dirty="0">
+              <a:sym typeface="Wingdings" pitchFamily="2" charset="2"/>
+            </a:endParaRPr>
           </a:p>
         </p:txBody>
       </p:sp>
     </p:spTree>
     <p:extLst>
       <p:ext uri="{BB962C8B-B14F-4D97-AF65-F5344CB8AC3E}">
-        <p14:creationId xmlns:p14="http://schemas.microsoft.com/office/powerpoint/2010/main" val="2560738612"/>
+        <p14:creationId xmlns:p14="http://schemas.microsoft.com/office/powerpoint/2010/main" val="2111695230"/>
       </p:ext>
     </p:extLst>
   </p:cSld>
@@ -10554,18 +10368,6 @@
                 <a:schemeClr val="accent5"/>
               </a:solidFill>
             </a:endParaRPr>
-          </a:p>
-          <a:p>
-            <a:pPr marL="457200" indent="-457200">
-              <a:buBlip>
-                <a:blip r:embed="rId2"/>
-              </a:buBlip>
-            </a:pPr>
-            <a:r>
-              <a:rPr lang="en-US" b="1" dirty="0"/>
-              <a:t>Let’s try it out</a:t>
-            </a:r>
-            <a:endParaRPr lang="en-US" sz="1800" dirty="0"/>
           </a:p>
         </p:txBody>
       </p:sp>
@@ -10916,6 +10718,201 @@
     <p:extLst>
       <p:ext uri="{BB962C8B-B14F-4D97-AF65-F5344CB8AC3E}">
         <p14:creationId xmlns:p14="http://schemas.microsoft.com/office/powerpoint/2010/main" val="4030677490"/>
+      </p:ext>
+    </p:extLst>
+  </p:cSld>
+  <p:clrMapOvr>
+    <a:masterClrMapping/>
+  </p:clrMapOvr>
+</p:sld>
+</file>
+
+<file path=ppt/slides/slide16.xml><?xml version="1.0" encoding="utf-8"?>
+<p:sld xmlns:a="http://schemas.openxmlformats.org/drawingml/2006/main" xmlns:r="http://schemas.openxmlformats.org/officeDocument/2006/relationships" xmlns:p="http://schemas.openxmlformats.org/presentationml/2006/main">
+  <p:cSld>
+    <p:spTree>
+      <p:nvGrpSpPr>
+        <p:cNvPr id="1" name="">
+          <a:extLst>
+            <a:ext uri="{FF2B5EF4-FFF2-40B4-BE49-F238E27FC236}">
+              <a16:creationId xmlns:a16="http://schemas.microsoft.com/office/drawing/2014/main" id="{B6065CDC-4A20-E3F6-7364-EE69704BDDCF}"/>
+            </a:ext>
+          </a:extLst>
+        </p:cNvPr>
+        <p:cNvGrpSpPr/>
+        <p:nvPr/>
+      </p:nvGrpSpPr>
+      <p:grpSpPr>
+        <a:xfrm>
+          <a:off x="0" y="0"/>
+          <a:ext cx="0" cy="0"/>
+          <a:chOff x="0" y="0"/>
+          <a:chExt cx="0" cy="0"/>
+        </a:xfrm>
+      </p:grpSpPr>
+      <p:sp>
+        <p:nvSpPr>
+          <p:cNvPr id="2" name="Title 1">
+            <a:extLst>
+              <a:ext uri="{FF2B5EF4-FFF2-40B4-BE49-F238E27FC236}">
+                <a16:creationId xmlns:a16="http://schemas.microsoft.com/office/drawing/2014/main" id="{892F676D-0AAC-4611-666E-625265F27DCB}"/>
+              </a:ext>
+            </a:extLst>
+          </p:cNvPr>
+          <p:cNvSpPr>
+            <a:spLocks noGrp="1"/>
+          </p:cNvSpPr>
+          <p:nvPr>
+            <p:ph type="title"/>
+          </p:nvPr>
+        </p:nvSpPr>
+        <p:spPr>
+          <a:xfrm>
+            <a:off x="0" y="0"/>
+            <a:ext cx="11353800" cy="972913"/>
+          </a:xfrm>
+        </p:spPr>
+        <p:txBody>
+          <a:bodyPr wrap="square" lIns="360000" tIns="180000" rIns="360000" bIns="180000">
+            <a:spAutoFit/>
+          </a:bodyPr>
+          <a:lstStyle/>
+          <a:p>
+            <a:r>
+              <a:rPr lang="en-AU" b="1" dirty="0">
+                <a:solidFill>
+                  <a:schemeClr val="accent6"/>
+                </a:solidFill>
+              </a:rPr>
+              <a:t>Practicing Markdown</a:t>
+            </a:r>
+          </a:p>
+        </p:txBody>
+      </p:sp>
+      <p:sp>
+        <p:nvSpPr>
+          <p:cNvPr id="3" name="Content Placeholder 2">
+            <a:extLst>
+              <a:ext uri="{FF2B5EF4-FFF2-40B4-BE49-F238E27FC236}">
+                <a16:creationId xmlns:a16="http://schemas.microsoft.com/office/drawing/2014/main" id="{5B6B532C-598F-F033-0DBD-BF4057A0FFE9}"/>
+              </a:ext>
+            </a:extLst>
+          </p:cNvPr>
+          <p:cNvSpPr>
+            <a:spLocks noGrp="1"/>
+          </p:cNvSpPr>
+          <p:nvPr>
+            <p:ph idx="1"/>
+          </p:nvPr>
+        </p:nvSpPr>
+        <p:spPr>
+          <a:xfrm>
+            <a:off x="0" y="972913"/>
+            <a:ext cx="11353800" cy="5885087"/>
+          </a:xfrm>
+        </p:spPr>
+        <p:txBody>
+          <a:bodyPr lIns="360000" tIns="180000" rIns="360000" bIns="180000">
+            <a:normAutofit/>
+          </a:bodyPr>
+          <a:lstStyle/>
+          <a:p>
+            <a:pPr marL="457200" indent="-457200">
+              <a:lnSpc>
+                <a:spcPct val="100000"/>
+              </a:lnSpc>
+              <a:buBlip>
+                <a:blip r:embed="rId2"/>
+              </a:buBlip>
+            </a:pPr>
+            <a:r>
+              <a:rPr lang="en-AU" dirty="0"/>
+              <a:t>Open VS Code</a:t>
+            </a:r>
+          </a:p>
+          <a:p>
+            <a:pPr marL="457200" indent="-457200">
+              <a:lnSpc>
+                <a:spcPct val="100000"/>
+              </a:lnSpc>
+              <a:buBlip>
+                <a:blip r:embed="rId2"/>
+              </a:buBlip>
+            </a:pPr>
+            <a:r>
+              <a:rPr lang="en-AU" dirty="0">
+                <a:sym typeface="Wingdings" pitchFamily="2" charset="2"/>
+              </a:rPr>
+              <a:t>File  New Text File</a:t>
+            </a:r>
+          </a:p>
+          <a:p>
+            <a:pPr marL="457200" indent="-457200">
+              <a:lnSpc>
+                <a:spcPct val="100000"/>
+              </a:lnSpc>
+              <a:buBlip>
+                <a:blip r:embed="rId2"/>
+              </a:buBlip>
+            </a:pPr>
+            <a:r>
+              <a:rPr lang="en-AU" dirty="0">
+                <a:sym typeface="Wingdings" pitchFamily="2" charset="2"/>
+              </a:rPr>
+              <a:t>Save the file and add the extension .md</a:t>
+            </a:r>
+          </a:p>
+          <a:p>
+            <a:pPr marL="457200" indent="-457200">
+              <a:lnSpc>
+                <a:spcPct val="100000"/>
+              </a:lnSpc>
+              <a:buBlip>
+                <a:blip r:embed="rId2"/>
+              </a:buBlip>
+            </a:pPr>
+            <a:r>
+              <a:rPr lang="en-AU" dirty="0">
+                <a:sym typeface="Wingdings" pitchFamily="2" charset="2"/>
+              </a:rPr>
+              <a:t>Practice writing in Markdown and check the layout using the Markdown Editor</a:t>
+            </a:r>
+          </a:p>
+          <a:p>
+            <a:pPr marL="457200" indent="-457200">
+              <a:lnSpc>
+                <a:spcPct val="100000"/>
+              </a:lnSpc>
+              <a:buBlip>
+                <a:blip r:embed="rId2"/>
+              </a:buBlip>
+            </a:pPr>
+            <a:r>
+              <a:rPr lang="en-AU" dirty="0">
+                <a:sym typeface="Wingdings" pitchFamily="2" charset="2"/>
+              </a:rPr>
+              <a:t>Commit the Markdown using instructions from previous slides</a:t>
+            </a:r>
+          </a:p>
+          <a:p>
+            <a:pPr marL="687600" lvl="1" indent="-457200">
+              <a:lnSpc>
+                <a:spcPct val="100000"/>
+              </a:lnSpc>
+              <a:buBlip>
+                <a:blip r:embed="rId2"/>
+              </a:buBlip>
+            </a:pPr>
+            <a:endParaRPr lang="en-AU" dirty="0">
+              <a:sym typeface="Wingdings" pitchFamily="2" charset="2"/>
+            </a:endParaRPr>
+          </a:p>
+        </p:txBody>
+      </p:sp>
+    </p:spTree>
+    <p:extLst>
+      <p:ext uri="{BB962C8B-B14F-4D97-AF65-F5344CB8AC3E}">
+        <p14:creationId xmlns:p14="http://schemas.microsoft.com/office/powerpoint/2010/main" val="1491122701"/>
       </p:ext>
     </p:extLst>
   </p:cSld>

</xml_diff>

<commit_message>
fixed typo in slides
</commit_message>
<xml_diff>
--- a/Week 1/wk1_PHYS3116_2026T3_spotted_python_slides.pptx
+++ b/Week 1/wk1_PHYS3116_2026T3_spotted_python_slides.pptx
@@ -7,28 +7,26 @@
     <p:sldMasterId id="2147483681" r:id="rId6"/>
   </p:sldMasterIdLst>
   <p:notesMasterIdLst>
-    <p:notesMasterId r:id="rId23"/>
+    <p:notesMasterId r:id="rId21"/>
   </p:notesMasterIdLst>
   <p:handoutMasterIdLst>
-    <p:handoutMasterId r:id="rId24"/>
+    <p:handoutMasterId r:id="rId22"/>
   </p:handoutMasterIdLst>
   <p:sldIdLst>
     <p:sldId id="258" r:id="rId7"/>
     <p:sldId id="288" r:id="rId8"/>
-    <p:sldId id="305" r:id="rId9"/>
-    <p:sldId id="306" r:id="rId10"/>
-    <p:sldId id="303" r:id="rId11"/>
-    <p:sldId id="304" r:id="rId12"/>
-    <p:sldId id="289" r:id="rId13"/>
-    <p:sldId id="290" r:id="rId14"/>
-    <p:sldId id="291" r:id="rId15"/>
-    <p:sldId id="292" r:id="rId16"/>
-    <p:sldId id="307" r:id="rId17"/>
-    <p:sldId id="308" r:id="rId18"/>
-    <p:sldId id="309" r:id="rId19"/>
-    <p:sldId id="310" r:id="rId20"/>
-    <p:sldId id="298" r:id="rId21"/>
-    <p:sldId id="311" r:id="rId22"/>
+    <p:sldId id="306" r:id="rId9"/>
+    <p:sldId id="303" r:id="rId10"/>
+    <p:sldId id="289" r:id="rId11"/>
+    <p:sldId id="290" r:id="rId12"/>
+    <p:sldId id="291" r:id="rId13"/>
+    <p:sldId id="292" r:id="rId14"/>
+    <p:sldId id="307" r:id="rId15"/>
+    <p:sldId id="308" r:id="rId16"/>
+    <p:sldId id="309" r:id="rId17"/>
+    <p:sldId id="310" r:id="rId18"/>
+    <p:sldId id="298" r:id="rId19"/>
+    <p:sldId id="311" r:id="rId20"/>
   </p:sldIdLst>
   <p:sldSz cx="12192000" cy="6858000"/>
   <p:notesSz cx="6858000" cy="9144000"/>
@@ -742,7 +740,7 @@
           <a:p>
             <a:fld id="{6246ACD0-BE8A-3D4B-8E89-B0E6ACFF594E}" type="slidenum">
               <a:rPr lang="en-US" smtClean="0"/>
-              <a:t>5</a:t>
+              <a:t>4</a:t>
             </a:fld>
             <a:endParaRPr lang="en-US"/>
           </a:p>
@@ -8975,509 +8973,6 @@
         <p:cNvPr id="1" name="">
           <a:extLst>
             <a:ext uri="{FF2B5EF4-FFF2-40B4-BE49-F238E27FC236}">
-              <a16:creationId xmlns:a16="http://schemas.microsoft.com/office/drawing/2014/main" id="{3AE3FC5C-7D8F-24B7-EAD9-CCCC38F1311E}"/>
-            </a:ext>
-          </a:extLst>
-        </p:cNvPr>
-        <p:cNvGrpSpPr/>
-        <p:nvPr/>
-      </p:nvGrpSpPr>
-      <p:grpSpPr>
-        <a:xfrm>
-          <a:off x="0" y="0"/>
-          <a:ext cx="0" cy="0"/>
-          <a:chOff x="0" y="0"/>
-          <a:chExt cx="0" cy="0"/>
-        </a:xfrm>
-      </p:grpSpPr>
-      <p:sp>
-        <p:nvSpPr>
-          <p:cNvPr id="2" name="Title 1">
-            <a:extLst>
-              <a:ext uri="{FF2B5EF4-FFF2-40B4-BE49-F238E27FC236}">
-                <a16:creationId xmlns:a16="http://schemas.microsoft.com/office/drawing/2014/main" id="{086E919C-F597-3A55-0251-72B1EBDA113C}"/>
-              </a:ext>
-            </a:extLst>
-          </p:cNvPr>
-          <p:cNvSpPr>
-            <a:spLocks noGrp="1"/>
-          </p:cNvSpPr>
-          <p:nvPr>
-            <p:ph type="title"/>
-          </p:nvPr>
-        </p:nvSpPr>
-        <p:spPr>
-          <a:xfrm>
-            <a:off x="0" y="0"/>
-            <a:ext cx="11353800" cy="972913"/>
-          </a:xfrm>
-        </p:spPr>
-        <p:txBody>
-          <a:bodyPr wrap="square" lIns="360000" tIns="180000" rIns="360000" bIns="180000">
-            <a:spAutoFit/>
-          </a:bodyPr>
-          <a:lstStyle/>
-          <a:p>
-            <a:r>
-              <a:rPr lang="en-AU" b="1" dirty="0">
-                <a:solidFill>
-                  <a:schemeClr val="accent6"/>
-                </a:solidFill>
-              </a:rPr>
-              <a:t>Making a new repository</a:t>
-            </a:r>
-          </a:p>
-        </p:txBody>
-      </p:sp>
-      <p:sp>
-        <p:nvSpPr>
-          <p:cNvPr id="3" name="Content Placeholder 2">
-            <a:extLst>
-              <a:ext uri="{FF2B5EF4-FFF2-40B4-BE49-F238E27FC236}">
-                <a16:creationId xmlns:a16="http://schemas.microsoft.com/office/drawing/2014/main" id="{E768F328-C1E5-D793-2646-F9138213B929}"/>
-              </a:ext>
-            </a:extLst>
-          </p:cNvPr>
-          <p:cNvSpPr>
-            <a:spLocks noGrp="1"/>
-          </p:cNvSpPr>
-          <p:nvPr>
-            <p:ph idx="1"/>
-          </p:nvPr>
-        </p:nvSpPr>
-        <p:spPr>
-          <a:xfrm>
-            <a:off x="0" y="972913"/>
-            <a:ext cx="6985747" cy="5885087"/>
-          </a:xfrm>
-        </p:spPr>
-        <p:txBody>
-          <a:bodyPr lIns="360000" tIns="180000" rIns="360000" bIns="180000">
-            <a:normAutofit/>
-          </a:bodyPr>
-          <a:lstStyle/>
-          <a:p>
-            <a:pPr marL="457200" indent="-457200">
-              <a:lnSpc>
-                <a:spcPct val="100000"/>
-              </a:lnSpc>
-              <a:buBlip>
-                <a:blip r:embed="rId2"/>
-              </a:buBlip>
-            </a:pPr>
-            <a:r>
-              <a:rPr lang="en-AU" dirty="0"/>
-              <a:t>Open GitHub Desktop</a:t>
-            </a:r>
-          </a:p>
-          <a:p>
-            <a:pPr marL="457200" indent="-457200">
-              <a:lnSpc>
-                <a:spcPct val="100000"/>
-              </a:lnSpc>
-              <a:buBlip>
-                <a:blip r:embed="rId2"/>
-              </a:buBlip>
-            </a:pPr>
-            <a:r>
-              <a:rPr lang="en-AU" dirty="0"/>
-              <a:t>Select File </a:t>
-            </a:r>
-            <a:r>
-              <a:rPr lang="en-AU" dirty="0">
-                <a:sym typeface="Wingdings" pitchFamily="2" charset="2"/>
-              </a:rPr>
-              <a:t> New Repository</a:t>
-            </a:r>
-          </a:p>
-          <a:p>
-            <a:pPr marL="457200" indent="-457200">
-              <a:lnSpc>
-                <a:spcPct val="100000"/>
-              </a:lnSpc>
-              <a:buBlip>
-                <a:blip r:embed="rId2"/>
-              </a:buBlip>
-            </a:pPr>
-            <a:r>
-              <a:rPr lang="en-AU" dirty="0">
-                <a:sym typeface="Wingdings" pitchFamily="2" charset="2"/>
-              </a:rPr>
-              <a:t>Enter the name, location you want to save the repository, a description, and tick “Initialize this repository with a README”</a:t>
-            </a:r>
-          </a:p>
-          <a:p>
-            <a:pPr marL="457200" indent="-457200">
-              <a:lnSpc>
-                <a:spcPct val="100000"/>
-              </a:lnSpc>
-              <a:buBlip>
-                <a:blip r:embed="rId2"/>
-              </a:buBlip>
-            </a:pPr>
-            <a:r>
-              <a:rPr lang="en-AU" dirty="0">
-                <a:sym typeface="Wingdings" pitchFamily="2" charset="2"/>
-              </a:rPr>
-              <a:t>Check that the file now exists locally on your laptop</a:t>
-            </a:r>
-          </a:p>
-          <a:p>
-            <a:pPr marL="457200" indent="-457200">
-              <a:lnSpc>
-                <a:spcPct val="100000"/>
-              </a:lnSpc>
-              <a:buBlip>
-                <a:blip r:embed="rId2"/>
-              </a:buBlip>
-            </a:pPr>
-            <a:r>
-              <a:rPr lang="en-AU" dirty="0">
-                <a:sym typeface="Wingdings" pitchFamily="2" charset="2"/>
-              </a:rPr>
-              <a:t>Publish the repository</a:t>
-            </a:r>
-            <a:endParaRPr lang="en-AU" dirty="0"/>
-          </a:p>
-        </p:txBody>
-      </p:sp>
-      <p:pic>
-        <p:nvPicPr>
-          <p:cNvPr id="7" name="Picture 6">
-            <a:extLst>
-              <a:ext uri="{FF2B5EF4-FFF2-40B4-BE49-F238E27FC236}">
-                <a16:creationId xmlns:a16="http://schemas.microsoft.com/office/drawing/2014/main" id="{914077BD-518A-3DD4-00C7-C2DA908E8177}"/>
-              </a:ext>
-            </a:extLst>
-          </p:cNvPr>
-          <p:cNvPicPr>
-            <a:picLocks noChangeAspect="1"/>
-          </p:cNvPicPr>
-          <p:nvPr/>
-        </p:nvPicPr>
-        <p:blipFill>
-          <a:blip r:embed="rId3"/>
-          <a:srcRect l="3887" t="3013" r="2202" b="2224"/>
-          <a:stretch>
-            <a:fillRect/>
-          </a:stretch>
-        </p:blipFill>
-        <p:spPr>
-          <a:xfrm>
-            <a:off x="6985747" y="1161173"/>
-            <a:ext cx="4065494" cy="5040390"/>
-          </a:xfrm>
-          <a:prstGeom prst="rect">
-            <a:avLst/>
-          </a:prstGeom>
-        </p:spPr>
-      </p:pic>
-      <p:pic>
-        <p:nvPicPr>
-          <p:cNvPr id="9" name="Picture 8">
-            <a:extLst>
-              <a:ext uri="{FF2B5EF4-FFF2-40B4-BE49-F238E27FC236}">
-                <a16:creationId xmlns:a16="http://schemas.microsoft.com/office/drawing/2014/main" id="{3175D8BF-ACDD-83C8-4C71-2B7E135A0327}"/>
-              </a:ext>
-            </a:extLst>
-          </p:cNvPr>
-          <p:cNvPicPr>
-            <a:picLocks noChangeAspect="1"/>
-          </p:cNvPicPr>
-          <p:nvPr/>
-        </p:nvPicPr>
-        <p:blipFill>
-          <a:blip r:embed="rId4"/>
-          <a:srcRect l="2404" t="4260" r="1617" b="2924"/>
-          <a:stretch>
-            <a:fillRect/>
-          </a:stretch>
-        </p:blipFill>
-        <p:spPr>
-          <a:xfrm>
-            <a:off x="4269442" y="4546952"/>
-            <a:ext cx="2716305" cy="2205620"/>
-          </a:xfrm>
-          <a:prstGeom prst="rect">
-            <a:avLst/>
-          </a:prstGeom>
-        </p:spPr>
-      </p:pic>
-    </p:spTree>
-    <p:extLst>
-      <p:ext uri="{BB962C8B-B14F-4D97-AF65-F5344CB8AC3E}">
-        <p14:creationId xmlns:p14="http://schemas.microsoft.com/office/powerpoint/2010/main" val="3190064017"/>
-      </p:ext>
-    </p:extLst>
-  </p:cSld>
-  <p:clrMapOvr>
-    <a:masterClrMapping/>
-  </p:clrMapOvr>
-</p:sld>
-</file>
-
-<file path=ppt/slides/slide11.xml><?xml version="1.0" encoding="utf-8"?>
-<p:sld xmlns:a="http://schemas.openxmlformats.org/drawingml/2006/main" xmlns:r="http://schemas.openxmlformats.org/officeDocument/2006/relationships" xmlns:p="http://schemas.openxmlformats.org/presentationml/2006/main">
-  <p:cSld>
-    <p:spTree>
-      <p:nvGrpSpPr>
-        <p:cNvPr id="1" name="">
-          <a:extLst>
-            <a:ext uri="{FF2B5EF4-FFF2-40B4-BE49-F238E27FC236}">
-              <a16:creationId xmlns:a16="http://schemas.microsoft.com/office/drawing/2014/main" id="{FDAC033A-0FEA-7F6C-5EC8-6AA173AFF0EF}"/>
-            </a:ext>
-          </a:extLst>
-        </p:cNvPr>
-        <p:cNvGrpSpPr/>
-        <p:nvPr/>
-      </p:nvGrpSpPr>
-      <p:grpSpPr>
-        <a:xfrm>
-          <a:off x="0" y="0"/>
-          <a:ext cx="0" cy="0"/>
-          <a:chOff x="0" y="0"/>
-          <a:chExt cx="0" cy="0"/>
-        </a:xfrm>
-      </p:grpSpPr>
-      <p:sp>
-        <p:nvSpPr>
-          <p:cNvPr id="2" name="Title 1">
-            <a:extLst>
-              <a:ext uri="{FF2B5EF4-FFF2-40B4-BE49-F238E27FC236}">
-                <a16:creationId xmlns:a16="http://schemas.microsoft.com/office/drawing/2014/main" id="{60ECE9E0-5F97-83EF-0165-65BA4EC0FF00}"/>
-              </a:ext>
-            </a:extLst>
-          </p:cNvPr>
-          <p:cNvSpPr>
-            <a:spLocks noGrp="1"/>
-          </p:cNvSpPr>
-          <p:nvPr>
-            <p:ph type="title"/>
-          </p:nvPr>
-        </p:nvSpPr>
-        <p:spPr>
-          <a:xfrm>
-            <a:off x="0" y="0"/>
-            <a:ext cx="11353800" cy="972913"/>
-          </a:xfrm>
-        </p:spPr>
-        <p:txBody>
-          <a:bodyPr wrap="square" lIns="360000" tIns="180000" rIns="360000" bIns="180000">
-            <a:spAutoFit/>
-          </a:bodyPr>
-          <a:lstStyle/>
-          <a:p>
-            <a:r>
-              <a:rPr lang="en-AU" b="1" dirty="0">
-                <a:solidFill>
-                  <a:schemeClr val="accent6"/>
-                </a:solidFill>
-              </a:rPr>
-              <a:t>Cloning a repository</a:t>
-            </a:r>
-          </a:p>
-        </p:txBody>
-      </p:sp>
-      <p:sp>
-        <p:nvSpPr>
-          <p:cNvPr id="3" name="Content Placeholder 2">
-            <a:extLst>
-              <a:ext uri="{FF2B5EF4-FFF2-40B4-BE49-F238E27FC236}">
-                <a16:creationId xmlns:a16="http://schemas.microsoft.com/office/drawing/2014/main" id="{1B4DAA17-B8B6-59B5-ECFA-78C20515AD91}"/>
-              </a:ext>
-            </a:extLst>
-          </p:cNvPr>
-          <p:cNvSpPr>
-            <a:spLocks noGrp="1"/>
-          </p:cNvSpPr>
-          <p:nvPr>
-            <p:ph idx="1"/>
-          </p:nvPr>
-        </p:nvSpPr>
-        <p:spPr>
-          <a:xfrm>
-            <a:off x="0" y="972913"/>
-            <a:ext cx="11353800" cy="5885087"/>
-          </a:xfrm>
-        </p:spPr>
-        <p:txBody>
-          <a:bodyPr lIns="360000" tIns="180000" rIns="360000" bIns="180000">
-            <a:normAutofit/>
-          </a:bodyPr>
-          <a:lstStyle/>
-          <a:p>
-            <a:pPr marL="457200" indent="-457200">
-              <a:lnSpc>
-                <a:spcPct val="100000"/>
-              </a:lnSpc>
-              <a:buBlip>
-                <a:blip r:embed="rId2"/>
-              </a:buBlip>
-            </a:pPr>
-            <a:r>
-              <a:rPr lang="en-AU" dirty="0"/>
-              <a:t>Go to GitHub website and check your repository is published</a:t>
-            </a:r>
-          </a:p>
-          <a:p>
-            <a:pPr marL="457200" indent="-457200">
-              <a:lnSpc>
-                <a:spcPct val="100000"/>
-              </a:lnSpc>
-              <a:buBlip>
-                <a:blip r:embed="rId2"/>
-              </a:buBlip>
-            </a:pPr>
-            <a:r>
-              <a:rPr lang="en-AU" dirty="0">
-                <a:sym typeface="Wingdings" pitchFamily="2" charset="2"/>
-              </a:rPr>
-              <a:t>We will now clone my repository that you will use for weekly resources</a:t>
-            </a:r>
-          </a:p>
-          <a:p>
-            <a:pPr marL="687600" lvl="1" indent="-457200">
-              <a:lnSpc>
-                <a:spcPct val="100000"/>
-              </a:lnSpc>
-              <a:buBlip>
-                <a:blip r:embed="rId2"/>
-              </a:buBlip>
-            </a:pPr>
-            <a:r>
-              <a:rPr lang="en-AU" dirty="0">
-                <a:sym typeface="Wingdings" pitchFamily="2" charset="2"/>
-              </a:rPr>
-              <a:t>Copy this link: </a:t>
-            </a:r>
-            <a:r>
-              <a:rPr lang="en-AU" dirty="0">
-                <a:sym typeface="Wingdings" pitchFamily="2" charset="2"/>
-                <a:hlinkClick r:id="rId3"/>
-              </a:rPr>
-              <a:t>https://github.com/mithebell/PHYS3116_2026T3.git</a:t>
-            </a:r>
-            <a:endParaRPr lang="en-AU" dirty="0">
-              <a:sym typeface="Wingdings" pitchFamily="2" charset="2"/>
-            </a:endParaRPr>
-          </a:p>
-          <a:p>
-            <a:pPr marL="687600" lvl="1" indent="-457200">
-              <a:lnSpc>
-                <a:spcPct val="100000"/>
-              </a:lnSpc>
-              <a:buBlip>
-                <a:blip r:embed="rId2"/>
-              </a:buBlip>
-            </a:pPr>
-            <a:r>
-              <a:rPr lang="en-AU" dirty="0">
-                <a:sym typeface="Wingdings" pitchFamily="2" charset="2"/>
-              </a:rPr>
-              <a:t>Go back to GitHub Desktop</a:t>
-            </a:r>
-          </a:p>
-          <a:p>
-            <a:pPr marL="687600" lvl="1" indent="-457200">
-              <a:lnSpc>
-                <a:spcPct val="100000"/>
-              </a:lnSpc>
-              <a:buBlip>
-                <a:blip r:embed="rId2"/>
-              </a:buBlip>
-            </a:pPr>
-            <a:r>
-              <a:rPr lang="en-AU" dirty="0">
-                <a:sym typeface="Wingdings" pitchFamily="2" charset="2"/>
-              </a:rPr>
-              <a:t>File  Clone Repository  URL</a:t>
-            </a:r>
-          </a:p>
-          <a:p>
-            <a:pPr marL="687600" lvl="1" indent="-457200">
-              <a:lnSpc>
-                <a:spcPct val="100000"/>
-              </a:lnSpc>
-              <a:buBlip>
-                <a:blip r:embed="rId2"/>
-              </a:buBlip>
-            </a:pPr>
-            <a:r>
-              <a:rPr lang="en-AU" dirty="0">
-                <a:sym typeface="Wingdings" pitchFamily="2" charset="2"/>
-              </a:rPr>
-              <a:t>Paste in the link and clone</a:t>
-            </a:r>
-          </a:p>
-          <a:p>
-            <a:pPr marL="457200" indent="-457200">
-              <a:lnSpc>
-                <a:spcPct val="100000"/>
-              </a:lnSpc>
-              <a:buBlip>
-                <a:blip r:embed="rId2"/>
-              </a:buBlip>
-            </a:pPr>
-            <a:r>
-              <a:rPr lang="en-AU" dirty="0">
-                <a:sym typeface="Wingdings" pitchFamily="2" charset="2"/>
-              </a:rPr>
-              <a:t>To push or</a:t>
-            </a:r>
-          </a:p>
-        </p:txBody>
-      </p:sp>
-      <p:pic>
-        <p:nvPicPr>
-          <p:cNvPr id="5" name="Picture 4">
-            <a:extLst>
-              <a:ext uri="{FF2B5EF4-FFF2-40B4-BE49-F238E27FC236}">
-                <a16:creationId xmlns:a16="http://schemas.microsoft.com/office/drawing/2014/main" id="{B76D1947-782B-240B-180C-1E45FB7BE636}"/>
-              </a:ext>
-            </a:extLst>
-          </p:cNvPr>
-          <p:cNvPicPr>
-            <a:picLocks noChangeAspect="1"/>
-          </p:cNvPicPr>
-          <p:nvPr/>
-        </p:nvPicPr>
-        <p:blipFill>
-          <a:blip r:embed="rId4"/>
-          <a:stretch>
-            <a:fillRect/>
-          </a:stretch>
-        </p:blipFill>
-        <p:spPr>
-          <a:xfrm>
-            <a:off x="5676900" y="3351703"/>
-            <a:ext cx="5463241" cy="3145842"/>
-          </a:xfrm>
-          <a:prstGeom prst="rect">
-            <a:avLst/>
-          </a:prstGeom>
-        </p:spPr>
-      </p:pic>
-    </p:spTree>
-    <p:extLst>
-      <p:ext uri="{BB962C8B-B14F-4D97-AF65-F5344CB8AC3E}">
-        <p14:creationId xmlns:p14="http://schemas.microsoft.com/office/powerpoint/2010/main" val="829449871"/>
-      </p:ext>
-    </p:extLst>
-  </p:cSld>
-  <p:clrMapOvr>
-    <a:masterClrMapping/>
-  </p:clrMapOvr>
-</p:sld>
-</file>
-
-<file path=ppt/slides/slide12.xml><?xml version="1.0" encoding="utf-8"?>
-<p:sld xmlns:a="http://schemas.openxmlformats.org/drawingml/2006/main" xmlns:r="http://schemas.openxmlformats.org/officeDocument/2006/relationships" xmlns:p="http://schemas.openxmlformats.org/presentationml/2006/main">
-  <p:cSld>
-    <p:spTree>
-      <p:nvGrpSpPr>
-        <p:cNvPr id="1" name="">
-          <a:extLst>
-            <a:ext uri="{FF2B5EF4-FFF2-40B4-BE49-F238E27FC236}">
               <a16:creationId xmlns:a16="http://schemas.microsoft.com/office/drawing/2014/main" id="{7DAD99B8-9885-CC79-9E5F-F2BE36CBCBD5}"/>
             </a:ext>
           </a:extLst>
@@ -9732,7 +9227,7 @@
 </p:sld>
 </file>
 
-<file path=ppt/slides/slide13.xml><?xml version="1.0" encoding="utf-8"?>
+<file path=ppt/slides/slide11.xml><?xml version="1.0" encoding="utf-8"?>
 <p:sld xmlns:a="http://schemas.openxmlformats.org/drawingml/2006/main" xmlns:r="http://schemas.openxmlformats.org/officeDocument/2006/relationships" xmlns:p="http://schemas.openxmlformats.org/presentationml/2006/main">
   <p:cSld>
     <p:spTree>
@@ -9943,7 +9438,7 @@
 </p:sld>
 </file>
 
-<file path=ppt/slides/slide14.xml><?xml version="1.0" encoding="utf-8"?>
+<file path=ppt/slides/slide12.xml><?xml version="1.0" encoding="utf-8"?>
 <p:sld xmlns:a="http://schemas.openxmlformats.org/drawingml/2006/main" xmlns:r="http://schemas.openxmlformats.org/officeDocument/2006/relationships" xmlns:p="http://schemas.openxmlformats.org/presentationml/2006/main">
   <p:cSld>
     <p:spTree>
@@ -10057,7 +9552,7 @@
             </a:pPr>
             <a:r>
               <a:rPr lang="en-AU" dirty="0"/>
-              <a:t>Clone GitHub Desktop onto your laptop</a:t>
+              <a:t>Clone the GitHub repository onto your laptop</a:t>
             </a:r>
           </a:p>
           <a:p>
@@ -10184,7 +9679,7 @@
 </p:sld>
 </file>
 
-<file path=ppt/slides/slide15.xml><?xml version="1.0" encoding="utf-8"?>
+<file path=ppt/slides/slide13.xml><?xml version="1.0" encoding="utf-8"?>
 <p:sld xmlns:a="http://schemas.openxmlformats.org/drawingml/2006/main" xmlns:r="http://schemas.openxmlformats.org/officeDocument/2006/relationships" xmlns:p="http://schemas.openxmlformats.org/presentationml/2006/main">
   <p:cSld>
     <p:spTree>
@@ -10743,7 +10238,7 @@
 </p:sld>
 </file>
 
-<file path=ppt/slides/slide16.xml><?xml version="1.0" encoding="utf-8"?>
+<file path=ppt/slides/slide14.xml><?xml version="1.0" encoding="utf-8"?>
 <p:sld xmlns:a="http://schemas.openxmlformats.org/drawingml/2006/main" xmlns:r="http://schemas.openxmlformats.org/officeDocument/2006/relationships" xmlns:p="http://schemas.openxmlformats.org/presentationml/2006/main">
   <p:cSld>
     <p:spTree>
@@ -11260,166 +10755,6 @@
         <p:cNvPr id="1" name="">
           <a:extLst>
             <a:ext uri="{FF2B5EF4-FFF2-40B4-BE49-F238E27FC236}">
-              <a16:creationId xmlns:a16="http://schemas.microsoft.com/office/drawing/2014/main" id="{53D1D093-7A73-C8B7-EE61-0BAFE8FCE32E}"/>
-            </a:ext>
-          </a:extLst>
-        </p:cNvPr>
-        <p:cNvGrpSpPr/>
-        <p:nvPr/>
-      </p:nvGrpSpPr>
-      <p:grpSpPr>
-        <a:xfrm>
-          <a:off x="0" y="0"/>
-          <a:ext cx="0" cy="0"/>
-          <a:chOff x="0" y="0"/>
-          <a:chExt cx="0" cy="0"/>
-        </a:xfrm>
-      </p:grpSpPr>
-      <p:sp>
-        <p:nvSpPr>
-          <p:cNvPr id="2" name="Title 1">
-            <a:extLst>
-              <a:ext uri="{FF2B5EF4-FFF2-40B4-BE49-F238E27FC236}">
-                <a16:creationId xmlns:a16="http://schemas.microsoft.com/office/drawing/2014/main" id="{DAAA34CB-C3B0-9C3E-8482-36B9E1E1F2BF}"/>
-              </a:ext>
-            </a:extLst>
-          </p:cNvPr>
-          <p:cNvSpPr>
-            <a:spLocks noGrp="1"/>
-          </p:cNvSpPr>
-          <p:nvPr>
-            <p:ph type="title"/>
-          </p:nvPr>
-        </p:nvSpPr>
-        <p:spPr>
-          <a:xfrm>
-            <a:off x="0" y="0"/>
-            <a:ext cx="11353800" cy="972913"/>
-          </a:xfrm>
-        </p:spPr>
-        <p:txBody>
-          <a:bodyPr wrap="square" lIns="360000" tIns="180000" rIns="360000" bIns="180000">
-            <a:spAutoFit/>
-          </a:bodyPr>
-          <a:lstStyle/>
-          <a:p>
-            <a:r>
-              <a:rPr lang="en-AU" b="1" dirty="0">
-                <a:solidFill>
-                  <a:schemeClr val="accent6"/>
-                </a:solidFill>
-              </a:rPr>
-              <a:t>Welcome Spotted Pythons</a:t>
-            </a:r>
-          </a:p>
-        </p:txBody>
-      </p:sp>
-      <p:sp>
-        <p:nvSpPr>
-          <p:cNvPr id="3" name="Content Placeholder 2">
-            <a:extLst>
-              <a:ext uri="{FF2B5EF4-FFF2-40B4-BE49-F238E27FC236}">
-                <a16:creationId xmlns:a16="http://schemas.microsoft.com/office/drawing/2014/main" id="{7D29553E-8BFC-D51D-BA3B-3F8098DC45BD}"/>
-              </a:ext>
-            </a:extLst>
-          </p:cNvPr>
-          <p:cNvSpPr>
-            <a:spLocks noGrp="1"/>
-          </p:cNvSpPr>
-          <p:nvPr>
-            <p:ph idx="1"/>
-          </p:nvPr>
-        </p:nvSpPr>
-        <p:spPr>
-          <a:xfrm>
-            <a:off x="0" y="989375"/>
-            <a:ext cx="11353800" cy="4879249"/>
-          </a:xfrm>
-        </p:spPr>
-        <p:txBody>
-          <a:bodyPr lIns="360000" tIns="180000" rIns="360000" bIns="180000" anchor="ctr">
-            <a:normAutofit/>
-          </a:bodyPr>
-          <a:lstStyle/>
-          <a:p>
-            <a:pPr marL="457200" indent="-457200">
-              <a:lnSpc>
-                <a:spcPct val="100000"/>
-              </a:lnSpc>
-              <a:buBlip>
-                <a:blip r:embed="rId2"/>
-              </a:buBlip>
-            </a:pPr>
-            <a:r>
-              <a:rPr lang="en-AU" dirty="0"/>
-              <a:t>Coding is an important skill for astrophysics</a:t>
-            </a:r>
-          </a:p>
-          <a:p>
-            <a:pPr marL="457200" indent="-457200">
-              <a:lnSpc>
-                <a:spcPct val="100000"/>
-              </a:lnSpc>
-              <a:buBlip>
-                <a:blip r:embed="rId2"/>
-              </a:buBlip>
-            </a:pPr>
-            <a:r>
-              <a:rPr lang="en-AU" dirty="0"/>
-              <a:t>This stream is designed to learn coding at a slower pace</a:t>
-            </a:r>
-          </a:p>
-          <a:p>
-            <a:pPr marL="457200" indent="-457200">
-              <a:lnSpc>
-                <a:spcPct val="100000"/>
-              </a:lnSpc>
-              <a:buBlip>
-                <a:blip r:embed="rId2"/>
-              </a:buBlip>
-            </a:pPr>
-            <a:r>
-              <a:rPr lang="en-AU" dirty="0"/>
-              <a:t>All examples and materials are the same across the 2 streams, but approached in different ways</a:t>
-            </a:r>
-          </a:p>
-          <a:p>
-            <a:pPr marL="457200" indent="-457200">
-              <a:lnSpc>
-                <a:spcPct val="100000"/>
-              </a:lnSpc>
-              <a:buBlip>
-                <a:blip r:embed="rId2"/>
-              </a:buBlip>
-            </a:pPr>
-            <a:r>
-              <a:rPr lang="en-AU" dirty="0"/>
-              <a:t>Finn will be the tutor for Morelia</a:t>
-            </a:r>
-          </a:p>
-        </p:txBody>
-      </p:sp>
-    </p:spTree>
-    <p:extLst>
-      <p:ext uri="{BB962C8B-B14F-4D97-AF65-F5344CB8AC3E}">
-        <p14:creationId xmlns:p14="http://schemas.microsoft.com/office/powerpoint/2010/main" val="2039195017"/>
-      </p:ext>
-    </p:extLst>
-  </p:cSld>
-  <p:clrMapOvr>
-    <a:masterClrMapping/>
-  </p:clrMapOvr>
-</p:sld>
-</file>
-
-<file path=ppt/slides/slide4.xml><?xml version="1.0" encoding="utf-8"?>
-<p:sld xmlns:a="http://schemas.openxmlformats.org/drawingml/2006/main" xmlns:r="http://schemas.openxmlformats.org/officeDocument/2006/relationships" xmlns:p="http://schemas.openxmlformats.org/presentationml/2006/main">
-  <p:cSld>
-    <p:spTree>
-      <p:nvGrpSpPr>
-        <p:cNvPr id="1" name="">
-          <a:extLst>
-            <a:ext uri="{FF2B5EF4-FFF2-40B4-BE49-F238E27FC236}">
               <a16:creationId xmlns:a16="http://schemas.microsoft.com/office/drawing/2014/main" id="{14B5F3D2-AB4A-81B1-310F-2D2FD260FE73}"/>
             </a:ext>
           </a:extLst>
@@ -11558,7 +10893,7 @@
 </p:sld>
 </file>
 
-<file path=ppt/slides/slide5.xml><?xml version="1.0" encoding="utf-8"?>
+<file path=ppt/slides/slide4.xml><?xml version="1.0" encoding="utf-8"?>
 <p:sld xmlns:a="http://schemas.openxmlformats.org/drawingml/2006/main" xmlns:r="http://schemas.openxmlformats.org/officeDocument/2006/relationships" xmlns:p="http://schemas.openxmlformats.org/presentationml/2006/main">
   <p:cSld>
     <p:spTree>
@@ -11843,153 +11178,7 @@
 </p:sld>
 </file>
 
-<file path=ppt/slides/slide6.xml><?xml version="1.0" encoding="utf-8"?>
-<p:sld xmlns:a="http://schemas.openxmlformats.org/drawingml/2006/main" xmlns:r="http://schemas.openxmlformats.org/officeDocument/2006/relationships" xmlns:p="http://schemas.openxmlformats.org/presentationml/2006/main">
-  <p:cSld>
-    <p:spTree>
-      <p:nvGrpSpPr>
-        <p:cNvPr id="1" name="">
-          <a:extLst>
-            <a:ext uri="{FF2B5EF4-FFF2-40B4-BE49-F238E27FC236}">
-              <a16:creationId xmlns:a16="http://schemas.microsoft.com/office/drawing/2014/main" id="{6C654519-031C-ECFF-C188-F49A14B2B11F}"/>
-            </a:ext>
-          </a:extLst>
-        </p:cNvPr>
-        <p:cNvGrpSpPr/>
-        <p:nvPr/>
-      </p:nvGrpSpPr>
-      <p:grpSpPr>
-        <a:xfrm>
-          <a:off x="0" y="0"/>
-          <a:ext cx="0" cy="0"/>
-          <a:chOff x="0" y="0"/>
-          <a:chExt cx="0" cy="0"/>
-        </a:xfrm>
-      </p:grpSpPr>
-      <p:sp>
-        <p:nvSpPr>
-          <p:cNvPr id="2" name="Title 1">
-            <a:extLst>
-              <a:ext uri="{FF2B5EF4-FFF2-40B4-BE49-F238E27FC236}">
-                <a16:creationId xmlns:a16="http://schemas.microsoft.com/office/drawing/2014/main" id="{E891ADE8-5CA7-C811-D7AF-BE6949DC0AA0}"/>
-              </a:ext>
-            </a:extLst>
-          </p:cNvPr>
-          <p:cNvSpPr>
-            <a:spLocks noGrp="1"/>
-          </p:cNvSpPr>
-          <p:nvPr>
-            <p:ph type="title"/>
-          </p:nvPr>
-        </p:nvSpPr>
-        <p:spPr>
-          <a:xfrm>
-            <a:off x="0" y="0"/>
-            <a:ext cx="11353800" cy="972913"/>
-          </a:xfrm>
-        </p:spPr>
-        <p:txBody>
-          <a:bodyPr wrap="square" lIns="360000" tIns="180000" rIns="360000" bIns="180000">
-            <a:spAutoFit/>
-          </a:bodyPr>
-          <a:lstStyle/>
-          <a:p>
-            <a:r>
-              <a:rPr lang="en-AU" b="1" dirty="0">
-                <a:solidFill>
-                  <a:schemeClr val="accent6"/>
-                </a:solidFill>
-              </a:rPr>
-              <a:t>I want to hear from you</a:t>
-            </a:r>
-          </a:p>
-        </p:txBody>
-      </p:sp>
-      <p:sp>
-        <p:nvSpPr>
-          <p:cNvPr id="3" name="Content Placeholder 2">
-            <a:extLst>
-              <a:ext uri="{FF2B5EF4-FFF2-40B4-BE49-F238E27FC236}">
-                <a16:creationId xmlns:a16="http://schemas.microsoft.com/office/drawing/2014/main" id="{98AB7CDF-0098-7BCC-6ECB-E1830C8D5672}"/>
-              </a:ext>
-            </a:extLst>
-          </p:cNvPr>
-          <p:cNvSpPr>
-            <a:spLocks noGrp="1"/>
-          </p:cNvSpPr>
-          <p:nvPr>
-            <p:ph idx="1"/>
-          </p:nvPr>
-        </p:nvSpPr>
-        <p:spPr>
-          <a:xfrm>
-            <a:off x="-1" y="972912"/>
-            <a:ext cx="11353799" cy="5885087"/>
-          </a:xfrm>
-        </p:spPr>
-        <p:txBody>
-          <a:bodyPr lIns="360000" tIns="180000" rIns="360000" bIns="180000">
-            <a:normAutofit/>
-          </a:bodyPr>
-          <a:lstStyle/>
-          <a:p>
-            <a:pPr marL="457200" indent="-457200">
-              <a:lnSpc>
-                <a:spcPct val="120000"/>
-              </a:lnSpc>
-              <a:buBlip>
-                <a:blip r:embed="rId2"/>
-              </a:buBlip>
-            </a:pPr>
-            <a:r>
-              <a:rPr lang="en-AU" dirty="0"/>
-              <a:t>What is your name</a:t>
-            </a:r>
-          </a:p>
-          <a:p>
-            <a:pPr marL="457200" indent="-457200">
-              <a:lnSpc>
-                <a:spcPct val="120000"/>
-              </a:lnSpc>
-              <a:buBlip>
-                <a:blip r:embed="rId2"/>
-              </a:buBlip>
-            </a:pPr>
-            <a:r>
-              <a:rPr lang="en-AU" dirty="0"/>
-              <a:t>What part of astronomy are you most excited about to learn/most interested in?</a:t>
-            </a:r>
-          </a:p>
-          <a:p>
-            <a:pPr marL="457200" indent="-457200">
-              <a:lnSpc>
-                <a:spcPct val="120000"/>
-              </a:lnSpc>
-              <a:buBlip>
-                <a:blip r:embed="rId2"/>
-              </a:buBlip>
-            </a:pPr>
-            <a:r>
-              <a:rPr lang="en-AU" dirty="0"/>
-              <a:t>Please give me feedback. I want you to govern what these tutorials are about!</a:t>
-            </a:r>
-          </a:p>
-        </p:txBody>
-      </p:sp>
-    </p:spTree>
-    <p:extLst>
-      <p:ext uri="{BB962C8B-B14F-4D97-AF65-F5344CB8AC3E}">
-        <p14:creationId xmlns:p14="http://schemas.microsoft.com/office/powerpoint/2010/main" val="3353981067"/>
-      </p:ext>
-    </p:extLst>
-  </p:cSld>
-  <p:clrMapOvr>
-    <a:masterClrMapping/>
-  </p:clrMapOvr>
-</p:sld>
-</file>
-
-<file path=ppt/slides/slide7.xml><?xml version="1.0" encoding="utf-8"?>
+<file path=ppt/slides/slide5.xml><?xml version="1.0" encoding="utf-8"?>
 <p:sld xmlns:a="http://schemas.openxmlformats.org/drawingml/2006/main" xmlns:r="http://schemas.openxmlformats.org/officeDocument/2006/relationships" xmlns:p="http://schemas.openxmlformats.org/presentationml/2006/main">
   <p:cSld>
     <p:spTree>
@@ -12261,7 +11450,7 @@
 </p:sld>
 </file>
 
-<file path=ppt/slides/slide8.xml><?xml version="1.0" encoding="utf-8"?>
+<file path=ppt/slides/slide6.xml><?xml version="1.0" encoding="utf-8"?>
 <p:sld xmlns:a="http://schemas.openxmlformats.org/drawingml/2006/main" xmlns:r="http://schemas.openxmlformats.org/officeDocument/2006/relationships" xmlns:p="http://schemas.openxmlformats.org/presentationml/2006/main">
   <p:cSld>
     <p:spTree>
@@ -12539,7 +11728,7 @@
 </p:sld>
 </file>
 
-<file path=ppt/slides/slide9.xml><?xml version="1.0" encoding="utf-8"?>
+<file path=ppt/slides/slide7.xml><?xml version="1.0" encoding="utf-8"?>
 <p:sld xmlns:a="http://schemas.openxmlformats.org/drawingml/2006/main" xmlns:r="http://schemas.openxmlformats.org/officeDocument/2006/relationships" xmlns:p="http://schemas.openxmlformats.org/presentationml/2006/main">
   <p:cSld>
     <p:spTree>
@@ -12776,6 +11965,505 @@
     <p:extLst>
       <p:ext uri="{BB962C8B-B14F-4D97-AF65-F5344CB8AC3E}">
         <p14:creationId xmlns:p14="http://schemas.microsoft.com/office/powerpoint/2010/main" val="2837446479"/>
+      </p:ext>
+    </p:extLst>
+  </p:cSld>
+  <p:clrMapOvr>
+    <a:masterClrMapping/>
+  </p:clrMapOvr>
+</p:sld>
+</file>
+
+<file path=ppt/slides/slide8.xml><?xml version="1.0" encoding="utf-8"?>
+<p:sld xmlns:a="http://schemas.openxmlformats.org/drawingml/2006/main" xmlns:r="http://schemas.openxmlformats.org/officeDocument/2006/relationships" xmlns:p="http://schemas.openxmlformats.org/presentationml/2006/main">
+  <p:cSld>
+    <p:spTree>
+      <p:nvGrpSpPr>
+        <p:cNvPr id="1" name="">
+          <a:extLst>
+            <a:ext uri="{FF2B5EF4-FFF2-40B4-BE49-F238E27FC236}">
+              <a16:creationId xmlns:a16="http://schemas.microsoft.com/office/drawing/2014/main" id="{3AE3FC5C-7D8F-24B7-EAD9-CCCC38F1311E}"/>
+            </a:ext>
+          </a:extLst>
+        </p:cNvPr>
+        <p:cNvGrpSpPr/>
+        <p:nvPr/>
+      </p:nvGrpSpPr>
+      <p:grpSpPr>
+        <a:xfrm>
+          <a:off x="0" y="0"/>
+          <a:ext cx="0" cy="0"/>
+          <a:chOff x="0" y="0"/>
+          <a:chExt cx="0" cy="0"/>
+        </a:xfrm>
+      </p:grpSpPr>
+      <p:sp>
+        <p:nvSpPr>
+          <p:cNvPr id="2" name="Title 1">
+            <a:extLst>
+              <a:ext uri="{FF2B5EF4-FFF2-40B4-BE49-F238E27FC236}">
+                <a16:creationId xmlns:a16="http://schemas.microsoft.com/office/drawing/2014/main" id="{086E919C-F597-3A55-0251-72B1EBDA113C}"/>
+              </a:ext>
+            </a:extLst>
+          </p:cNvPr>
+          <p:cNvSpPr>
+            <a:spLocks noGrp="1"/>
+          </p:cNvSpPr>
+          <p:nvPr>
+            <p:ph type="title"/>
+          </p:nvPr>
+        </p:nvSpPr>
+        <p:spPr>
+          <a:xfrm>
+            <a:off x="0" y="0"/>
+            <a:ext cx="11353800" cy="972913"/>
+          </a:xfrm>
+        </p:spPr>
+        <p:txBody>
+          <a:bodyPr wrap="square" lIns="360000" tIns="180000" rIns="360000" bIns="180000">
+            <a:spAutoFit/>
+          </a:bodyPr>
+          <a:lstStyle/>
+          <a:p>
+            <a:r>
+              <a:rPr lang="en-AU" b="1" dirty="0">
+                <a:solidFill>
+                  <a:schemeClr val="accent6"/>
+                </a:solidFill>
+              </a:rPr>
+              <a:t>Making a new repository</a:t>
+            </a:r>
+          </a:p>
+        </p:txBody>
+      </p:sp>
+      <p:sp>
+        <p:nvSpPr>
+          <p:cNvPr id="3" name="Content Placeholder 2">
+            <a:extLst>
+              <a:ext uri="{FF2B5EF4-FFF2-40B4-BE49-F238E27FC236}">
+                <a16:creationId xmlns:a16="http://schemas.microsoft.com/office/drawing/2014/main" id="{E768F328-C1E5-D793-2646-F9138213B929}"/>
+              </a:ext>
+            </a:extLst>
+          </p:cNvPr>
+          <p:cNvSpPr>
+            <a:spLocks noGrp="1"/>
+          </p:cNvSpPr>
+          <p:nvPr>
+            <p:ph idx="1"/>
+          </p:nvPr>
+        </p:nvSpPr>
+        <p:spPr>
+          <a:xfrm>
+            <a:off x="0" y="972913"/>
+            <a:ext cx="6985747" cy="5885087"/>
+          </a:xfrm>
+        </p:spPr>
+        <p:txBody>
+          <a:bodyPr lIns="360000" tIns="180000" rIns="360000" bIns="180000">
+            <a:normAutofit/>
+          </a:bodyPr>
+          <a:lstStyle/>
+          <a:p>
+            <a:pPr marL="457200" indent="-457200">
+              <a:lnSpc>
+                <a:spcPct val="100000"/>
+              </a:lnSpc>
+              <a:buBlip>
+                <a:blip r:embed="rId2"/>
+              </a:buBlip>
+            </a:pPr>
+            <a:r>
+              <a:rPr lang="en-AU" dirty="0"/>
+              <a:t>Open GitHub Desktop</a:t>
+            </a:r>
+          </a:p>
+          <a:p>
+            <a:pPr marL="457200" indent="-457200">
+              <a:lnSpc>
+                <a:spcPct val="100000"/>
+              </a:lnSpc>
+              <a:buBlip>
+                <a:blip r:embed="rId2"/>
+              </a:buBlip>
+            </a:pPr>
+            <a:r>
+              <a:rPr lang="en-AU" dirty="0"/>
+              <a:t>Select File </a:t>
+            </a:r>
+            <a:r>
+              <a:rPr lang="en-AU" dirty="0">
+                <a:sym typeface="Wingdings" pitchFamily="2" charset="2"/>
+              </a:rPr>
+              <a:t> New Repository</a:t>
+            </a:r>
+          </a:p>
+          <a:p>
+            <a:pPr marL="457200" indent="-457200">
+              <a:lnSpc>
+                <a:spcPct val="100000"/>
+              </a:lnSpc>
+              <a:buBlip>
+                <a:blip r:embed="rId2"/>
+              </a:buBlip>
+            </a:pPr>
+            <a:r>
+              <a:rPr lang="en-AU" dirty="0">
+                <a:sym typeface="Wingdings" pitchFamily="2" charset="2"/>
+              </a:rPr>
+              <a:t>Enter the name, location you want to save the repository, a description, and tick “Initialize this repository with a README”</a:t>
+            </a:r>
+          </a:p>
+          <a:p>
+            <a:pPr marL="457200" indent="-457200">
+              <a:lnSpc>
+                <a:spcPct val="100000"/>
+              </a:lnSpc>
+              <a:buBlip>
+                <a:blip r:embed="rId2"/>
+              </a:buBlip>
+            </a:pPr>
+            <a:r>
+              <a:rPr lang="en-AU" dirty="0">
+                <a:sym typeface="Wingdings" pitchFamily="2" charset="2"/>
+              </a:rPr>
+              <a:t>Check that the file now exists locally on your laptop</a:t>
+            </a:r>
+          </a:p>
+          <a:p>
+            <a:pPr marL="457200" indent="-457200">
+              <a:lnSpc>
+                <a:spcPct val="100000"/>
+              </a:lnSpc>
+              <a:buBlip>
+                <a:blip r:embed="rId2"/>
+              </a:buBlip>
+            </a:pPr>
+            <a:r>
+              <a:rPr lang="en-AU" dirty="0">
+                <a:sym typeface="Wingdings" pitchFamily="2" charset="2"/>
+              </a:rPr>
+              <a:t>Publish the repository</a:t>
+            </a:r>
+            <a:endParaRPr lang="en-AU" dirty="0"/>
+          </a:p>
+        </p:txBody>
+      </p:sp>
+      <p:pic>
+        <p:nvPicPr>
+          <p:cNvPr id="7" name="Picture 6">
+            <a:extLst>
+              <a:ext uri="{FF2B5EF4-FFF2-40B4-BE49-F238E27FC236}">
+                <a16:creationId xmlns:a16="http://schemas.microsoft.com/office/drawing/2014/main" id="{914077BD-518A-3DD4-00C7-C2DA908E8177}"/>
+              </a:ext>
+            </a:extLst>
+          </p:cNvPr>
+          <p:cNvPicPr>
+            <a:picLocks noChangeAspect="1"/>
+          </p:cNvPicPr>
+          <p:nvPr/>
+        </p:nvPicPr>
+        <p:blipFill>
+          <a:blip r:embed="rId3"/>
+          <a:srcRect l="3887" t="3013" r="2202" b="2224"/>
+          <a:stretch>
+            <a:fillRect/>
+          </a:stretch>
+        </p:blipFill>
+        <p:spPr>
+          <a:xfrm>
+            <a:off x="6985747" y="1161173"/>
+            <a:ext cx="4065494" cy="5040390"/>
+          </a:xfrm>
+          <a:prstGeom prst="rect">
+            <a:avLst/>
+          </a:prstGeom>
+        </p:spPr>
+      </p:pic>
+      <p:pic>
+        <p:nvPicPr>
+          <p:cNvPr id="9" name="Picture 8">
+            <a:extLst>
+              <a:ext uri="{FF2B5EF4-FFF2-40B4-BE49-F238E27FC236}">
+                <a16:creationId xmlns:a16="http://schemas.microsoft.com/office/drawing/2014/main" id="{3175D8BF-ACDD-83C8-4C71-2B7E135A0327}"/>
+              </a:ext>
+            </a:extLst>
+          </p:cNvPr>
+          <p:cNvPicPr>
+            <a:picLocks noChangeAspect="1"/>
+          </p:cNvPicPr>
+          <p:nvPr/>
+        </p:nvPicPr>
+        <p:blipFill>
+          <a:blip r:embed="rId4"/>
+          <a:srcRect l="2404" t="4260" r="1617" b="2924"/>
+          <a:stretch>
+            <a:fillRect/>
+          </a:stretch>
+        </p:blipFill>
+        <p:spPr>
+          <a:xfrm>
+            <a:off x="4269442" y="4546952"/>
+            <a:ext cx="2716305" cy="2205620"/>
+          </a:xfrm>
+          <a:prstGeom prst="rect">
+            <a:avLst/>
+          </a:prstGeom>
+        </p:spPr>
+      </p:pic>
+    </p:spTree>
+    <p:extLst>
+      <p:ext uri="{BB962C8B-B14F-4D97-AF65-F5344CB8AC3E}">
+        <p14:creationId xmlns:p14="http://schemas.microsoft.com/office/powerpoint/2010/main" val="3190064017"/>
+      </p:ext>
+    </p:extLst>
+  </p:cSld>
+  <p:clrMapOvr>
+    <a:masterClrMapping/>
+  </p:clrMapOvr>
+</p:sld>
+</file>
+
+<file path=ppt/slides/slide9.xml><?xml version="1.0" encoding="utf-8"?>
+<p:sld xmlns:a="http://schemas.openxmlformats.org/drawingml/2006/main" xmlns:r="http://schemas.openxmlformats.org/officeDocument/2006/relationships" xmlns:p="http://schemas.openxmlformats.org/presentationml/2006/main">
+  <p:cSld>
+    <p:spTree>
+      <p:nvGrpSpPr>
+        <p:cNvPr id="1" name="">
+          <a:extLst>
+            <a:ext uri="{FF2B5EF4-FFF2-40B4-BE49-F238E27FC236}">
+              <a16:creationId xmlns:a16="http://schemas.microsoft.com/office/drawing/2014/main" id="{FDAC033A-0FEA-7F6C-5EC8-6AA173AFF0EF}"/>
+            </a:ext>
+          </a:extLst>
+        </p:cNvPr>
+        <p:cNvGrpSpPr/>
+        <p:nvPr/>
+      </p:nvGrpSpPr>
+      <p:grpSpPr>
+        <a:xfrm>
+          <a:off x="0" y="0"/>
+          <a:ext cx="0" cy="0"/>
+          <a:chOff x="0" y="0"/>
+          <a:chExt cx="0" cy="0"/>
+        </a:xfrm>
+      </p:grpSpPr>
+      <p:sp>
+        <p:nvSpPr>
+          <p:cNvPr id="2" name="Title 1">
+            <a:extLst>
+              <a:ext uri="{FF2B5EF4-FFF2-40B4-BE49-F238E27FC236}">
+                <a16:creationId xmlns:a16="http://schemas.microsoft.com/office/drawing/2014/main" id="{60ECE9E0-5F97-83EF-0165-65BA4EC0FF00}"/>
+              </a:ext>
+            </a:extLst>
+          </p:cNvPr>
+          <p:cNvSpPr>
+            <a:spLocks noGrp="1"/>
+          </p:cNvSpPr>
+          <p:nvPr>
+            <p:ph type="title"/>
+          </p:nvPr>
+        </p:nvSpPr>
+        <p:spPr>
+          <a:xfrm>
+            <a:off x="0" y="0"/>
+            <a:ext cx="11353800" cy="972913"/>
+          </a:xfrm>
+        </p:spPr>
+        <p:txBody>
+          <a:bodyPr wrap="square" lIns="360000" tIns="180000" rIns="360000" bIns="180000">
+            <a:spAutoFit/>
+          </a:bodyPr>
+          <a:lstStyle/>
+          <a:p>
+            <a:r>
+              <a:rPr lang="en-AU" b="1" dirty="0">
+                <a:solidFill>
+                  <a:schemeClr val="accent6"/>
+                </a:solidFill>
+              </a:rPr>
+              <a:t>Cloning a repository</a:t>
+            </a:r>
+          </a:p>
+        </p:txBody>
+      </p:sp>
+      <p:sp>
+        <p:nvSpPr>
+          <p:cNvPr id="3" name="Content Placeholder 2">
+            <a:extLst>
+              <a:ext uri="{FF2B5EF4-FFF2-40B4-BE49-F238E27FC236}">
+                <a16:creationId xmlns:a16="http://schemas.microsoft.com/office/drawing/2014/main" id="{1B4DAA17-B8B6-59B5-ECFA-78C20515AD91}"/>
+              </a:ext>
+            </a:extLst>
+          </p:cNvPr>
+          <p:cNvSpPr>
+            <a:spLocks noGrp="1"/>
+          </p:cNvSpPr>
+          <p:nvPr>
+            <p:ph idx="1"/>
+          </p:nvPr>
+        </p:nvSpPr>
+        <p:spPr>
+          <a:xfrm>
+            <a:off x="0" y="972913"/>
+            <a:ext cx="11353800" cy="5885087"/>
+          </a:xfrm>
+        </p:spPr>
+        <p:txBody>
+          <a:bodyPr lIns="360000" tIns="180000" rIns="360000" bIns="180000">
+            <a:normAutofit/>
+          </a:bodyPr>
+          <a:lstStyle/>
+          <a:p>
+            <a:pPr marL="457200" indent="-457200">
+              <a:lnSpc>
+                <a:spcPct val="100000"/>
+              </a:lnSpc>
+              <a:buBlip>
+                <a:blip r:embed="rId2"/>
+              </a:buBlip>
+            </a:pPr>
+            <a:r>
+              <a:rPr lang="en-AU" dirty="0"/>
+              <a:t>Go to GitHub website and check your repository is published</a:t>
+            </a:r>
+          </a:p>
+          <a:p>
+            <a:pPr marL="457200" indent="-457200">
+              <a:lnSpc>
+                <a:spcPct val="100000"/>
+              </a:lnSpc>
+              <a:buBlip>
+                <a:blip r:embed="rId2"/>
+              </a:buBlip>
+            </a:pPr>
+            <a:r>
+              <a:rPr lang="en-AU" dirty="0">
+                <a:sym typeface="Wingdings" pitchFamily="2" charset="2"/>
+              </a:rPr>
+              <a:t>We will now clone my repository that you will use for weekly resources</a:t>
+            </a:r>
+          </a:p>
+          <a:p>
+            <a:pPr marL="687600" lvl="1" indent="-457200">
+              <a:lnSpc>
+                <a:spcPct val="100000"/>
+              </a:lnSpc>
+              <a:buBlip>
+                <a:blip r:embed="rId2"/>
+              </a:buBlip>
+            </a:pPr>
+            <a:r>
+              <a:rPr lang="en-AU" dirty="0">
+                <a:sym typeface="Wingdings" pitchFamily="2" charset="2"/>
+              </a:rPr>
+              <a:t>Copy this link: </a:t>
+            </a:r>
+            <a:r>
+              <a:rPr lang="en-AU" dirty="0">
+                <a:solidFill>
+                  <a:schemeClr val="accent5"/>
+                </a:solidFill>
+                <a:sym typeface="Wingdings" pitchFamily="2" charset="2"/>
+                <a:hlinkClick r:id="rId3">
+                  <a:extLst>
+                    <a:ext uri="{A12FA001-AC4F-418D-AE19-62706E023703}">
+                      <ahyp:hlinkClr xmlns:ahyp="http://schemas.microsoft.com/office/drawing/2018/hyperlinkcolor" val="tx"/>
+                    </a:ext>
+                  </a:extLst>
+                </a:hlinkClick>
+              </a:rPr>
+              <a:t>https://github.com/mithebell/PHYS3116_2026T3.git</a:t>
+            </a:r>
+            <a:endParaRPr lang="en-AU" dirty="0">
+              <a:solidFill>
+                <a:schemeClr val="accent5"/>
+              </a:solidFill>
+              <a:sym typeface="Wingdings" pitchFamily="2" charset="2"/>
+            </a:endParaRPr>
+          </a:p>
+          <a:p>
+            <a:pPr marL="687600" lvl="1" indent="-457200">
+              <a:lnSpc>
+                <a:spcPct val="100000"/>
+              </a:lnSpc>
+              <a:buBlip>
+                <a:blip r:embed="rId2"/>
+              </a:buBlip>
+            </a:pPr>
+            <a:r>
+              <a:rPr lang="en-AU" dirty="0">
+                <a:sym typeface="Wingdings" pitchFamily="2" charset="2"/>
+              </a:rPr>
+              <a:t>Go back to GitHub Desktop</a:t>
+            </a:r>
+          </a:p>
+          <a:p>
+            <a:pPr marL="687600" lvl="1" indent="-457200">
+              <a:lnSpc>
+                <a:spcPct val="100000"/>
+              </a:lnSpc>
+              <a:buBlip>
+                <a:blip r:embed="rId2"/>
+              </a:buBlip>
+            </a:pPr>
+            <a:r>
+              <a:rPr lang="en-AU" dirty="0">
+                <a:sym typeface="Wingdings" pitchFamily="2" charset="2"/>
+              </a:rPr>
+              <a:t>File  Clone Repository  URL</a:t>
+            </a:r>
+          </a:p>
+          <a:p>
+            <a:pPr marL="687600" lvl="1" indent="-457200">
+              <a:lnSpc>
+                <a:spcPct val="100000"/>
+              </a:lnSpc>
+              <a:buBlip>
+                <a:blip r:embed="rId2"/>
+              </a:buBlip>
+            </a:pPr>
+            <a:r>
+              <a:rPr lang="en-AU" dirty="0">
+                <a:sym typeface="Wingdings" pitchFamily="2" charset="2"/>
+              </a:rPr>
+              <a:t>Paste in the link and clone</a:t>
+            </a:r>
+          </a:p>
+        </p:txBody>
+      </p:sp>
+      <p:pic>
+        <p:nvPicPr>
+          <p:cNvPr id="5" name="Picture 4">
+            <a:extLst>
+              <a:ext uri="{FF2B5EF4-FFF2-40B4-BE49-F238E27FC236}">
+                <a16:creationId xmlns:a16="http://schemas.microsoft.com/office/drawing/2014/main" id="{B76D1947-782B-240B-180C-1E45FB7BE636}"/>
+              </a:ext>
+            </a:extLst>
+          </p:cNvPr>
+          <p:cNvPicPr>
+            <a:picLocks noChangeAspect="1"/>
+          </p:cNvPicPr>
+          <p:nvPr/>
+        </p:nvPicPr>
+        <p:blipFill>
+          <a:blip r:embed="rId4"/>
+          <a:stretch>
+            <a:fillRect/>
+          </a:stretch>
+        </p:blipFill>
+        <p:spPr>
+          <a:xfrm>
+            <a:off x="5676900" y="3351703"/>
+            <a:ext cx="5463241" cy="3145842"/>
+          </a:xfrm>
+          <a:prstGeom prst="rect">
+            <a:avLst/>
+          </a:prstGeom>
+        </p:spPr>
+      </p:pic>
+    </p:spTree>
+    <p:extLst>
+      <p:ext uri="{BB962C8B-B14F-4D97-AF65-F5344CB8AC3E}">
+        <p14:creationId xmlns:p14="http://schemas.microsoft.com/office/powerpoint/2010/main" val="829449871"/>
       </p:ext>
     </p:extLst>
   </p:cSld>
@@ -13979,15 +13667,6 @@
 </file>
 
 <file path=customXml/item1.xml><?xml version="1.0" encoding="utf-8"?>
-<?mso-contentType ?>
-<FormTemplates xmlns="http://schemas.microsoft.com/sharepoint/v3/contenttype/forms">
-  <Display>DocumentLibraryForm</Display>
-  <Edit>DocumentLibraryForm</Edit>
-  <New>DocumentLibraryForm</New>
-</FormTemplates>
-</file>
-
-<file path=customXml/item2.xml><?xml version="1.0" encoding="utf-8"?>
 <p:properties xmlns:p="http://schemas.microsoft.com/office/2006/metadata/properties" xmlns:xsi="http://www.w3.org/2001/XMLSchema-instance" xmlns:pc="http://schemas.microsoft.com/office/infopath/2007/PartnerControls">
   <documentManagement>
     <TaxCatchAll xmlns="3d8a2230-54d9-4525-a072-aaf2ad3921af" xsi:nil="true"/>
@@ -13996,6 +13675,15 @@
     </lcf76f155ced4ddcb4097134ff3c332f>
   </documentManagement>
 </p:properties>
+</file>
+
+<file path=customXml/item2.xml><?xml version="1.0" encoding="utf-8"?>
+<?mso-contentType ?>
+<FormTemplates xmlns="http://schemas.microsoft.com/sharepoint/v3/contenttype/forms">
+  <Display>DocumentLibraryForm</Display>
+  <Edit>DocumentLibraryForm</Edit>
+  <New>DocumentLibraryForm</New>
+</FormTemplates>
 </file>
 
 <file path=customXml/item3.xml><?xml version="1.0" encoding="utf-8"?>
@@ -14242,20 +13930,20 @@
 </file>
 
 <file path=customXml/itemProps1.xml><?xml version="1.0" encoding="utf-8"?>
-<ds:datastoreItem xmlns:ds="http://schemas.openxmlformats.org/officeDocument/2006/customXml" ds:itemID="{76F36D4B-89AA-43AA-A4F8-41021B539501}">
-  <ds:schemaRefs>
-    <ds:schemaRef ds:uri="http://schemas.microsoft.com/sharepoint/v3/contenttype/forms"/>
-  </ds:schemaRefs>
-</ds:datastoreItem>
-</file>
-
-<file path=customXml/itemProps2.xml><?xml version="1.0" encoding="utf-8"?>
 <ds:datastoreItem xmlns:ds="http://schemas.openxmlformats.org/officeDocument/2006/customXml" ds:itemID="{B4CE31FE-9010-4DD9-ACBF-74A5EE27FA83}">
   <ds:schemaRefs>
     <ds:schemaRef ds:uri="http://schemas.microsoft.com/office/2006/metadata/properties"/>
     <ds:schemaRef ds:uri="http://schemas.microsoft.com/office/infopath/2007/PartnerControls"/>
     <ds:schemaRef ds:uri="3d8a2230-54d9-4525-a072-aaf2ad3921af"/>
     <ds:schemaRef ds:uri="3e861e5c-b9b4-4f4a-a39d-d4f58c595d50"/>
+  </ds:schemaRefs>
+</ds:datastoreItem>
+</file>
+
+<file path=customXml/itemProps2.xml><?xml version="1.0" encoding="utf-8"?>
+<ds:datastoreItem xmlns:ds="http://schemas.openxmlformats.org/officeDocument/2006/customXml" ds:itemID="{76F36D4B-89AA-43AA-A4F8-41021B539501}">
+  <ds:schemaRefs>
+    <ds:schemaRef ds:uri="http://schemas.microsoft.com/sharepoint/v3/contenttype/forms"/>
   </ds:schemaRefs>
 </ds:datastoreItem>
 </file>

</xml_diff>